<commit_message>
Add per-Q reference slides: worked example + FDA expectations (18 slides)
</commit_message>
<xml_diff>
--- a/slides/workshop-intro-slides.pptx
+++ b/slides/workshop-intro-slides.pptx
@@ -19,9 +19,13 @@
     <p:sldId id="267" r:id="rId13"/>
     <p:sldId id="268" r:id="rId14"/>
     <p:sldId id="269" r:id="rId15"/>
+    <p:sldId id="270" r:id="rId16"/>
+    <p:sldId id="271" r:id="rId17"/>
+    <p:sldId id="272" r:id="rId18"/>
+    <p:sldId id="273" r:id="rId19"/>
   </p:sldIdLst>
   <p:notesMasterIdLst>
-    <p:notesMasterId r:id="rId16"/>
+    <p:notesMasterId r:id="rId20"/>
   </p:notesMasterIdLst>
   <p:sldSz cx="12192000" cy="6858000"/>
   <p:notesSz cx="6858000" cy="12192000"/>
@@ -979,6 +983,358 @@
             <a:fld id="{F7021451-1387-4CA6-816F-3879F97B5CBC}" type="slidenum">
               <a:rPr lang="en-US"/>
               <a:t>14</a:t>
+            </a:fld>
+            <a:endParaRPr lang="en-US"/>
+          </a:p>
+        </p:txBody>
+      </p:sp>
+    </p:spTree>
+    <p:extLst>
+      <p:ext uri="{BB962C8B-B14F-4D97-AF65-F5344CB8AC3E}">
+        <p14:creationId xmlns:p14="http://schemas.microsoft.com/office/powerpoint/2010/main" val="1024086991"/>
+      </p:ext>
+    </p:extLst>
+  </p:cSld>
+  <p:clrMapOvr>
+    <a:masterClrMapping/>
+  </p:clrMapOvr>
+</p:notes>
+</file>
+
+<file path=ppt/notesSlides/notesSlide15.xml><?xml version="1.0" encoding="utf-8"?>
+<p:notes xmlns:a="http://schemas.openxmlformats.org/drawingml/2006/main" xmlns:r="http://schemas.openxmlformats.org/officeDocument/2006/relationships" xmlns:p="http://schemas.openxmlformats.org/presentationml/2006/main">
+  <p:cSld>
+    <p:spTree>
+      <p:nvGrpSpPr>
+        <p:cNvPr id="1" name=""/>
+        <p:cNvGrpSpPr/>
+        <p:nvPr/>
+      </p:nvGrpSpPr>
+      <p:grpSpPr>
+        <a:xfrm>
+          <a:off x="0" y="0"/>
+          <a:ext cx="0" cy="0"/>
+          <a:chOff x="0" y="0"/>
+          <a:chExt cx="0" cy="0"/>
+        </a:xfrm>
+      </p:grpSpPr>
+      <p:sp>
+        <p:nvSpPr>
+          <p:cNvPr id="2" name="Slide Image Placeholder 1"/>
+          <p:cNvSpPr>
+            <a:spLocks noGrp="1" noRot="1" noChangeAspect="1"/>
+          </p:cNvSpPr>
+          <p:nvPr>
+            <p:ph type="sldImg"/>
+          </p:nvPr>
+        </p:nvSpPr>
+        <p:spPr/>
+      </p:sp>
+      <p:sp>
+        <p:nvSpPr>
+          <p:cNvPr id="3" name="Notes Placeholder 2"/>
+          <p:cNvSpPr>
+            <a:spLocks noGrp="1"/>
+          </p:cNvSpPr>
+          <p:nvPr>
+            <p:ph type="body" idx="1"/>
+          </p:nvPr>
+        </p:nvSpPr>
+        <p:spPr/>
+        <p:txBody>
+          <a:bodyPr/>
+          <a:lstStyle/>
+          <a:p>
+            <a:r>
+              <a:rPr lang="en-US" dirty="0"/>
+              <a:t/>
+            </a:r>
+            <a:endParaRPr lang="en-US" dirty="0"/>
+          </a:p>
+        </p:txBody>
+      </p:sp>
+      <p:sp>
+        <p:nvSpPr>
+          <p:cNvPr id="4" name="Slide Number Placeholder 3"/>
+          <p:cNvSpPr>
+            <a:spLocks noGrp="1"/>
+          </p:cNvSpPr>
+          <p:nvPr>
+            <p:ph type="sldNum" sz="quarter" idx="10"/>
+          </p:nvPr>
+        </p:nvSpPr>
+        <p:spPr/>
+        <p:txBody>
+          <a:bodyPr/>
+          <a:lstStyle/>
+          <a:p>
+            <a:fld id="{F7021451-1387-4CA6-816F-3879F97B5CBC}" type="slidenum">
+              <a:rPr lang="en-US"/>
+              <a:t>15</a:t>
+            </a:fld>
+            <a:endParaRPr lang="en-US"/>
+          </a:p>
+        </p:txBody>
+      </p:sp>
+    </p:spTree>
+    <p:extLst>
+      <p:ext uri="{BB962C8B-B14F-4D97-AF65-F5344CB8AC3E}">
+        <p14:creationId xmlns:p14="http://schemas.microsoft.com/office/powerpoint/2010/main" val="1024086991"/>
+      </p:ext>
+    </p:extLst>
+  </p:cSld>
+  <p:clrMapOvr>
+    <a:masterClrMapping/>
+  </p:clrMapOvr>
+</p:notes>
+</file>
+
+<file path=ppt/notesSlides/notesSlide16.xml><?xml version="1.0" encoding="utf-8"?>
+<p:notes xmlns:a="http://schemas.openxmlformats.org/drawingml/2006/main" xmlns:r="http://schemas.openxmlformats.org/officeDocument/2006/relationships" xmlns:p="http://schemas.openxmlformats.org/presentationml/2006/main">
+  <p:cSld>
+    <p:spTree>
+      <p:nvGrpSpPr>
+        <p:cNvPr id="1" name=""/>
+        <p:cNvGrpSpPr/>
+        <p:nvPr/>
+      </p:nvGrpSpPr>
+      <p:grpSpPr>
+        <a:xfrm>
+          <a:off x="0" y="0"/>
+          <a:ext cx="0" cy="0"/>
+          <a:chOff x="0" y="0"/>
+          <a:chExt cx="0" cy="0"/>
+        </a:xfrm>
+      </p:grpSpPr>
+      <p:sp>
+        <p:nvSpPr>
+          <p:cNvPr id="2" name="Slide Image Placeholder 1"/>
+          <p:cNvSpPr>
+            <a:spLocks noGrp="1" noRot="1" noChangeAspect="1"/>
+          </p:cNvSpPr>
+          <p:nvPr>
+            <p:ph type="sldImg"/>
+          </p:nvPr>
+        </p:nvSpPr>
+        <p:spPr/>
+      </p:sp>
+      <p:sp>
+        <p:nvSpPr>
+          <p:cNvPr id="3" name="Notes Placeholder 2"/>
+          <p:cNvSpPr>
+            <a:spLocks noGrp="1"/>
+          </p:cNvSpPr>
+          <p:nvPr>
+            <p:ph type="body" idx="1"/>
+          </p:nvPr>
+        </p:nvSpPr>
+        <p:spPr/>
+        <p:txBody>
+          <a:bodyPr/>
+          <a:lstStyle/>
+          <a:p>
+            <a:r>
+              <a:rPr lang="en-US" dirty="0"/>
+              <a:t/>
+            </a:r>
+            <a:endParaRPr lang="en-US" dirty="0"/>
+          </a:p>
+        </p:txBody>
+      </p:sp>
+      <p:sp>
+        <p:nvSpPr>
+          <p:cNvPr id="4" name="Slide Number Placeholder 3"/>
+          <p:cNvSpPr>
+            <a:spLocks noGrp="1"/>
+          </p:cNvSpPr>
+          <p:nvPr>
+            <p:ph type="sldNum" sz="quarter" idx="10"/>
+          </p:nvPr>
+        </p:nvSpPr>
+        <p:spPr/>
+        <p:txBody>
+          <a:bodyPr/>
+          <a:lstStyle/>
+          <a:p>
+            <a:fld id="{F7021451-1387-4CA6-816F-3879F97B5CBC}" type="slidenum">
+              <a:rPr lang="en-US"/>
+              <a:t>16</a:t>
+            </a:fld>
+            <a:endParaRPr lang="en-US"/>
+          </a:p>
+        </p:txBody>
+      </p:sp>
+    </p:spTree>
+    <p:extLst>
+      <p:ext uri="{BB962C8B-B14F-4D97-AF65-F5344CB8AC3E}">
+        <p14:creationId xmlns:p14="http://schemas.microsoft.com/office/powerpoint/2010/main" val="1024086991"/>
+      </p:ext>
+    </p:extLst>
+  </p:cSld>
+  <p:clrMapOvr>
+    <a:masterClrMapping/>
+  </p:clrMapOvr>
+</p:notes>
+</file>
+
+<file path=ppt/notesSlides/notesSlide17.xml><?xml version="1.0" encoding="utf-8"?>
+<p:notes xmlns:a="http://schemas.openxmlformats.org/drawingml/2006/main" xmlns:r="http://schemas.openxmlformats.org/officeDocument/2006/relationships" xmlns:p="http://schemas.openxmlformats.org/presentationml/2006/main">
+  <p:cSld>
+    <p:spTree>
+      <p:nvGrpSpPr>
+        <p:cNvPr id="1" name=""/>
+        <p:cNvGrpSpPr/>
+        <p:nvPr/>
+      </p:nvGrpSpPr>
+      <p:grpSpPr>
+        <a:xfrm>
+          <a:off x="0" y="0"/>
+          <a:ext cx="0" cy="0"/>
+          <a:chOff x="0" y="0"/>
+          <a:chExt cx="0" cy="0"/>
+        </a:xfrm>
+      </p:grpSpPr>
+      <p:sp>
+        <p:nvSpPr>
+          <p:cNvPr id="2" name="Slide Image Placeholder 1"/>
+          <p:cNvSpPr>
+            <a:spLocks noGrp="1" noRot="1" noChangeAspect="1"/>
+          </p:cNvSpPr>
+          <p:nvPr>
+            <p:ph type="sldImg"/>
+          </p:nvPr>
+        </p:nvSpPr>
+        <p:spPr/>
+      </p:sp>
+      <p:sp>
+        <p:nvSpPr>
+          <p:cNvPr id="3" name="Notes Placeholder 2"/>
+          <p:cNvSpPr>
+            <a:spLocks noGrp="1"/>
+          </p:cNvSpPr>
+          <p:nvPr>
+            <p:ph type="body" idx="1"/>
+          </p:nvPr>
+        </p:nvSpPr>
+        <p:spPr/>
+        <p:txBody>
+          <a:bodyPr/>
+          <a:lstStyle/>
+          <a:p>
+            <a:r>
+              <a:rPr lang="en-US" dirty="0"/>
+              <a:t/>
+            </a:r>
+            <a:endParaRPr lang="en-US" dirty="0"/>
+          </a:p>
+        </p:txBody>
+      </p:sp>
+      <p:sp>
+        <p:nvSpPr>
+          <p:cNvPr id="4" name="Slide Number Placeholder 3"/>
+          <p:cNvSpPr>
+            <a:spLocks noGrp="1"/>
+          </p:cNvSpPr>
+          <p:nvPr>
+            <p:ph type="sldNum" sz="quarter" idx="10"/>
+          </p:nvPr>
+        </p:nvSpPr>
+        <p:spPr/>
+        <p:txBody>
+          <a:bodyPr/>
+          <a:lstStyle/>
+          <a:p>
+            <a:fld id="{F7021451-1387-4CA6-816F-3879F97B5CBC}" type="slidenum">
+              <a:rPr lang="en-US"/>
+              <a:t>17</a:t>
+            </a:fld>
+            <a:endParaRPr lang="en-US"/>
+          </a:p>
+        </p:txBody>
+      </p:sp>
+    </p:spTree>
+    <p:extLst>
+      <p:ext uri="{BB962C8B-B14F-4D97-AF65-F5344CB8AC3E}">
+        <p14:creationId xmlns:p14="http://schemas.microsoft.com/office/powerpoint/2010/main" val="1024086991"/>
+      </p:ext>
+    </p:extLst>
+  </p:cSld>
+  <p:clrMapOvr>
+    <a:masterClrMapping/>
+  </p:clrMapOvr>
+</p:notes>
+</file>
+
+<file path=ppt/notesSlides/notesSlide18.xml><?xml version="1.0" encoding="utf-8"?>
+<p:notes xmlns:a="http://schemas.openxmlformats.org/drawingml/2006/main" xmlns:r="http://schemas.openxmlformats.org/officeDocument/2006/relationships" xmlns:p="http://schemas.openxmlformats.org/presentationml/2006/main">
+  <p:cSld>
+    <p:spTree>
+      <p:nvGrpSpPr>
+        <p:cNvPr id="1" name=""/>
+        <p:cNvGrpSpPr/>
+        <p:nvPr/>
+      </p:nvGrpSpPr>
+      <p:grpSpPr>
+        <a:xfrm>
+          <a:off x="0" y="0"/>
+          <a:ext cx="0" cy="0"/>
+          <a:chOff x="0" y="0"/>
+          <a:chExt cx="0" cy="0"/>
+        </a:xfrm>
+      </p:grpSpPr>
+      <p:sp>
+        <p:nvSpPr>
+          <p:cNvPr id="2" name="Slide Image Placeholder 1"/>
+          <p:cNvSpPr>
+            <a:spLocks noGrp="1" noRot="1" noChangeAspect="1"/>
+          </p:cNvSpPr>
+          <p:nvPr>
+            <p:ph type="sldImg"/>
+          </p:nvPr>
+        </p:nvSpPr>
+        <p:spPr/>
+      </p:sp>
+      <p:sp>
+        <p:nvSpPr>
+          <p:cNvPr id="3" name="Notes Placeholder 2"/>
+          <p:cNvSpPr>
+            <a:spLocks noGrp="1"/>
+          </p:cNvSpPr>
+          <p:nvPr>
+            <p:ph type="body" idx="1"/>
+          </p:nvPr>
+        </p:nvSpPr>
+        <p:spPr/>
+        <p:txBody>
+          <a:bodyPr/>
+          <a:lstStyle/>
+          <a:p>
+            <a:r>
+              <a:rPr lang="en-US" dirty="0"/>
+              <a:t/>
+            </a:r>
+            <a:endParaRPr lang="en-US" dirty="0"/>
+          </a:p>
+        </p:txBody>
+      </p:sp>
+      <p:sp>
+        <p:nvSpPr>
+          <p:cNvPr id="4" name="Slide Number Placeholder 3"/>
+          <p:cNvSpPr>
+            <a:spLocks noGrp="1"/>
+          </p:cNvSpPr>
+          <p:nvPr>
+            <p:ph type="sldNum" sz="quarter" idx="10"/>
+          </p:nvPr>
+        </p:nvSpPr>
+        <p:spPr/>
+        <p:txBody>
+          <a:bodyPr/>
+          <a:lstStyle/>
+          <a:p>
+            <a:fld id="{F7021451-1387-4CA6-816F-3879F97B5CBC}" type="slidenum">
+              <a:rPr lang="en-US"/>
+              <a:t>18</a:t>
             </a:fld>
             <a:endParaRPr lang="en-US"/>
           </a:p>
@@ -2242,6 +2598,441 @@
     <p:bg>
       <p:bgPr>
         <a:solidFill>
+          <a:srgbClr val="07253A"/>
+        </a:solidFill>
+      </p:bgPr>
+    </p:bg>
+    <p:spTree>
+      <p:nvGrpSpPr>
+        <p:cNvPr id="1" name=""/>
+        <p:cNvGrpSpPr/>
+        <p:nvPr/>
+      </p:nvGrpSpPr>
+      <p:grpSpPr>
+        <a:xfrm>
+          <a:off x="0" y="0"/>
+          <a:ext cx="0" cy="0"/>
+          <a:chOff x="0" y="0"/>
+          <a:chExt cx="0" cy="0"/>
+        </a:xfrm>
+      </p:grpSpPr>
+      <p:sp>
+        <p:nvSpPr>
+          <p:cNvPr id="2" name="Shape 0"/>
+          <p:cNvSpPr/>
+          <p:nvPr/>
+        </p:nvSpPr>
+        <p:spPr>
+          <a:xfrm>
+            <a:off x="640080" y="548640"/>
+            <a:ext cx="868680" cy="868680"/>
+          </a:xfrm>
+          <a:prstGeom prst="ellipse">
+            <a:avLst/>
+          </a:prstGeom>
+          <a:solidFill>
+            <a:srgbClr val="02C39A"/>
+          </a:solidFill>
+          <a:ln/>
+        </p:spPr>
+      </p:sp>
+      <p:sp>
+        <p:nvSpPr>
+          <p:cNvPr id="3" name="Text 1"/>
+          <p:cNvSpPr/>
+          <p:nvPr/>
+        </p:nvSpPr>
+        <p:spPr>
+          <a:xfrm>
+            <a:off x="640080" y="548640"/>
+            <a:ext cx="868680" cy="868680"/>
+          </a:xfrm>
+          <a:prstGeom prst="rect">
+            <a:avLst/>
+          </a:prstGeom>
+          <a:noFill/>
+          <a:ln/>
+        </p:spPr>
+        <p:txBody>
+          <a:bodyPr wrap="square" lIns="0" tIns="0" rIns="0" bIns="0" rtlCol="0" anchor="ctr"/>
+          <a:lstStyle/>
+          <a:p>
+            <a:pPr algn="ctr" indent="0" marL="0">
+              <a:buNone/>
+            </a:pPr>
+            <a:r>
+              <a:rPr lang="en-US" sz="2200" b="1" dirty="0">
+                <a:solidFill>
+                  <a:srgbClr val="07253A"/>
+                </a:solidFill>
+                <a:latin typeface="Cambria" pitchFamily="34" charset="0"/>
+                <a:ea typeface="Cambria" pitchFamily="34" charset="-122"/>
+                <a:cs typeface="Cambria" pitchFamily="34" charset="-120"/>
+              </a:rPr>
+              <a:t>2</a:t>
+            </a:r>
+            <a:endParaRPr lang="en-US" sz="2200" dirty="0"/>
+          </a:p>
+        </p:txBody>
+      </p:sp>
+      <p:sp>
+        <p:nvSpPr>
+          <p:cNvPr id="4" name="Text 2"/>
+          <p:cNvSpPr/>
+          <p:nvPr/>
+        </p:nvSpPr>
+        <p:spPr>
+          <a:xfrm>
+            <a:off x="1737360" y="566928"/>
+            <a:ext cx="9875520" cy="868680"/>
+          </a:xfrm>
+          <a:prstGeom prst="rect">
+            <a:avLst/>
+          </a:prstGeom>
+          <a:noFill/>
+          <a:ln/>
+        </p:spPr>
+        <p:txBody>
+          <a:bodyPr wrap="square" lIns="0" tIns="0" rIns="0" bIns="0" rtlCol="0" anchor="ctr"/>
+          <a:lstStyle/>
+          <a:p>
+            <a:pPr indent="0" marL="0">
+              <a:buNone/>
+            </a:pPr>
+            <a:r>
+              <a:rPr lang="en-US" sz="3400" b="1" dirty="0">
+                <a:solidFill>
+                  <a:srgbClr val="FFFFFF"/>
+                </a:solidFill>
+                <a:latin typeface="Cambria" pitchFamily="34" charset="0"/>
+                <a:ea typeface="Cambria" pitchFamily="34" charset="-122"/>
+                <a:cs typeface="Cambria" pitchFamily="34" charset="-120"/>
+              </a:rPr>
+              <a:t>What can go wrong?</a:t>
+            </a:r>
+            <a:endParaRPr lang="en-US" sz="3400" dirty="0"/>
+          </a:p>
+        </p:txBody>
+      </p:sp>
+      <p:sp>
+        <p:nvSpPr>
+          <p:cNvPr id="5" name="Text 3"/>
+          <p:cNvSpPr/>
+          <p:nvPr/>
+        </p:nvSpPr>
+        <p:spPr>
+          <a:xfrm>
+            <a:off x="658368" y="1645920"/>
+            <a:ext cx="10607040" cy="548640"/>
+          </a:xfrm>
+          <a:prstGeom prst="rect">
+            <a:avLst/>
+          </a:prstGeom>
+          <a:noFill/>
+          <a:ln/>
+        </p:spPr>
+        <p:txBody>
+          <a:bodyPr wrap="square" lIns="0" tIns="0" rIns="0" bIns="0" rtlCol="0" anchor="ctr"/>
+          <a:lstStyle/>
+          <a:p>
+            <a:pPr indent="0" marL="0">
+              <a:buNone/>
+            </a:pPr>
+            <a:r>
+              <a:rPr lang="en-US" sz="1800" i="1" dirty="0">
+                <a:solidFill>
+                  <a:srgbClr val="BFE0E8"/>
+                </a:solidFill>
+                <a:latin typeface="Calibri" pitchFamily="34" charset="0"/>
+                <a:ea typeface="Calibri" pitchFamily="34" charset="-122"/>
+                <a:cs typeface="Calibri" pitchFamily="34" charset="-120"/>
+              </a:rPr>
+              <a:t>Think like an attacker. Write ATTACKER STORIES.</a:t>
+            </a:r>
+            <a:endParaRPr lang="en-US" sz="1800" dirty="0"/>
+          </a:p>
+        </p:txBody>
+      </p:sp>
+      <p:sp>
+        <p:nvSpPr>
+          <p:cNvPr id="6" name="Shape 4"/>
+          <p:cNvSpPr/>
+          <p:nvPr/>
+        </p:nvSpPr>
+        <p:spPr>
+          <a:xfrm>
+            <a:off x="822960" y="2468880"/>
+            <a:ext cx="10515600" cy="1554480"/>
+          </a:xfrm>
+          <a:prstGeom prst="roundRect">
+            <a:avLst>
+              <a:gd name="adj" fmla="val 7059"/>
+            </a:avLst>
+          </a:prstGeom>
+          <a:solidFill>
+            <a:srgbClr val="0E3A55"/>
+          </a:solidFill>
+          <a:ln w="19050">
+            <a:solidFill>
+              <a:srgbClr val="02C39A"/>
+            </a:solidFill>
+            <a:prstDash val="solid"/>
+          </a:ln>
+        </p:spPr>
+      </p:sp>
+      <p:sp>
+        <p:nvSpPr>
+          <p:cNvPr id="7" name="Text 5"/>
+          <p:cNvSpPr/>
+          <p:nvPr/>
+        </p:nvSpPr>
+        <p:spPr>
+          <a:xfrm>
+            <a:off x="1097280" y="2468880"/>
+            <a:ext cx="9966960" cy="1554480"/>
+          </a:xfrm>
+          <a:prstGeom prst="rect">
+            <a:avLst/>
+          </a:prstGeom>
+          <a:noFill/>
+          <a:ln/>
+        </p:spPr>
+        <p:txBody>
+          <a:bodyPr wrap="square" lIns="0" tIns="0" rIns="0" bIns="0" rtlCol="0" anchor="ctr"/>
+          <a:lstStyle/>
+          <a:p>
+            <a:pPr indent="0" marL="0">
+              <a:lnSpc>
+                <a:spcPct val="115000"/>
+              </a:lnSpc>
+              <a:buNone/>
+            </a:pPr>
+            <a:r>
+              <a:rPr lang="en-US" sz="2400" dirty="0">
+                <a:solidFill>
+                  <a:srgbClr val="BFE0E8"/>
+                </a:solidFill>
+                <a:latin typeface="Cambria" pitchFamily="34" charset="0"/>
+                <a:ea typeface="Cambria" pitchFamily="34" charset="-122"/>
+                <a:cs typeface="Cambria" pitchFamily="34" charset="-120"/>
+              </a:rPr>
+              <a:t>As a </a:t>
+            </a:r>
+            <a:pPr indent="0" marL="0">
+              <a:lnSpc>
+                <a:spcPct val="115000"/>
+              </a:lnSpc>
+              <a:buNone/>
+            </a:pPr>
+            <a:r>
+              <a:rPr lang="en-US" sz="2400" b="1" dirty="0">
+                <a:solidFill>
+                  <a:srgbClr val="02C39A"/>
+                </a:solidFill>
+                <a:latin typeface="Cambria" pitchFamily="34" charset="0"/>
+                <a:ea typeface="Cambria" pitchFamily="34" charset="-122"/>
+                <a:cs typeface="Cambria" pitchFamily="34" charset="-120"/>
+              </a:rPr>
+              <a:t>[bad actor]</a:t>
+            </a:r>
+            <a:pPr indent="0" marL="0">
+              <a:lnSpc>
+                <a:spcPct val="115000"/>
+              </a:lnSpc>
+              <a:buNone/>
+            </a:pPr>
+            <a:r>
+              <a:rPr lang="en-US" sz="2400" dirty="0">
+                <a:solidFill>
+                  <a:srgbClr val="BFE0E8"/>
+                </a:solidFill>
+                <a:latin typeface="Cambria" pitchFamily="34" charset="0"/>
+                <a:ea typeface="Cambria" pitchFamily="34" charset="-122"/>
+                <a:cs typeface="Cambria" pitchFamily="34" charset="-120"/>
+              </a:rPr>
+              <a:t>, I want to </a:t>
+            </a:r>
+            <a:pPr indent="0" marL="0">
+              <a:lnSpc>
+                <a:spcPct val="115000"/>
+              </a:lnSpc>
+              <a:buNone/>
+            </a:pPr>
+            <a:r>
+              <a:rPr lang="en-US" sz="2400" b="1" dirty="0">
+                <a:solidFill>
+                  <a:srgbClr val="02C39A"/>
+                </a:solidFill>
+                <a:latin typeface="Cambria" pitchFamily="34" charset="0"/>
+                <a:ea typeface="Cambria" pitchFamily="34" charset="-122"/>
+                <a:cs typeface="Cambria" pitchFamily="34" charset="-120"/>
+              </a:rPr>
+              <a:t>[do something bad]</a:t>
+            </a:r>
+            <a:pPr indent="0" marL="0">
+              <a:lnSpc>
+                <a:spcPct val="115000"/>
+              </a:lnSpc>
+              <a:buNone/>
+            </a:pPr>
+            <a:r>
+              <a:rPr lang="en-US" sz="2400" dirty="0">
+                <a:solidFill>
+                  <a:srgbClr val="BFE0E8"/>
+                </a:solidFill>
+                <a:latin typeface="Cambria" pitchFamily="34" charset="0"/>
+                <a:ea typeface="Cambria" pitchFamily="34" charset="-122"/>
+                <a:cs typeface="Cambria" pitchFamily="34" charset="-120"/>
+              </a:rPr>
+              <a:t> via </a:t>
+            </a:r>
+            <a:pPr indent="0" marL="0">
+              <a:lnSpc>
+                <a:spcPct val="115000"/>
+              </a:lnSpc>
+              <a:buNone/>
+            </a:pPr>
+            <a:r>
+              <a:rPr lang="en-US" sz="2400" b="1" dirty="0">
+                <a:solidFill>
+                  <a:srgbClr val="02C39A"/>
+                </a:solidFill>
+                <a:latin typeface="Cambria" pitchFamily="34" charset="0"/>
+                <a:ea typeface="Cambria" pitchFamily="34" charset="-122"/>
+                <a:cs typeface="Cambria" pitchFamily="34" charset="-120"/>
+              </a:rPr>
+              <a:t>[method]</a:t>
+            </a:r>
+            <a:pPr indent="0" marL="0">
+              <a:lnSpc>
+                <a:spcPct val="115000"/>
+              </a:lnSpc>
+              <a:buNone/>
+            </a:pPr>
+            <a:r>
+              <a:rPr lang="en-US" sz="2400" dirty="0">
+                <a:solidFill>
+                  <a:srgbClr val="BFE0E8"/>
+                </a:solidFill>
+                <a:latin typeface="Cambria" pitchFamily="34" charset="0"/>
+                <a:ea typeface="Cambria" pitchFamily="34" charset="-122"/>
+                <a:cs typeface="Cambria" pitchFamily="34" charset="-120"/>
+              </a:rPr>
+              <a:t>, so that </a:t>
+            </a:r>
+            <a:pPr indent="0" marL="0">
+              <a:lnSpc>
+                <a:spcPct val="115000"/>
+              </a:lnSpc>
+              <a:buNone/>
+            </a:pPr>
+            <a:r>
+              <a:rPr lang="en-US" sz="2400" b="1" dirty="0">
+                <a:solidFill>
+                  <a:srgbClr val="02C39A"/>
+                </a:solidFill>
+                <a:latin typeface="Cambria" pitchFamily="34" charset="0"/>
+                <a:ea typeface="Cambria" pitchFamily="34" charset="-122"/>
+                <a:cs typeface="Cambria" pitchFamily="34" charset="-120"/>
+              </a:rPr>
+              <a:t>[goal].</a:t>
+            </a:r>
+            <a:endParaRPr lang="en-US" sz="2400" dirty="0"/>
+          </a:p>
+        </p:txBody>
+      </p:sp>
+      <p:sp>
+        <p:nvSpPr>
+          <p:cNvPr id="8" name="Text 6"/>
+          <p:cNvSpPr/>
+          <p:nvPr/>
+        </p:nvSpPr>
+        <p:spPr>
+          <a:xfrm>
+            <a:off x="822960" y="4251960"/>
+            <a:ext cx="10515600" cy="1005840"/>
+          </a:xfrm>
+          <a:prstGeom prst="rect">
+            <a:avLst/>
+          </a:prstGeom>
+          <a:noFill/>
+          <a:ln/>
+        </p:spPr>
+        <p:txBody>
+          <a:bodyPr wrap="square" lIns="0" tIns="0" rIns="0" bIns="0" rtlCol="0" anchor="ctr"/>
+          <a:lstStyle/>
+          <a:p>
+            <a:pPr indent="0" marL="0">
+              <a:buNone/>
+            </a:pPr>
+            <a:r>
+              <a:rPr lang="en-US" sz="1600" i="1" dirty="0">
+                <a:solidFill>
+                  <a:srgbClr val="CDE3EA"/>
+                </a:solidFill>
+                <a:latin typeface="Calibri" pitchFamily="34" charset="0"/>
+                <a:ea typeface="Calibri" pitchFamily="34" charset="-122"/>
+                <a:cs typeface="Calibri" pitchFamily="34" charset="-120"/>
+              </a:rPr>
+              <a:t>Example: As a rogue vendor technician, I want to change the AI model via the remote support channel, so that the system returns false negatives and patients are misdiagnosed.</a:t>
+            </a:r>
+            <a:endParaRPr lang="en-US" sz="1600" dirty="0"/>
+          </a:p>
+        </p:txBody>
+      </p:sp>
+      <p:sp>
+        <p:nvSpPr>
+          <p:cNvPr id="9" name="Text 7"/>
+          <p:cNvSpPr/>
+          <p:nvPr/>
+        </p:nvSpPr>
+        <p:spPr>
+          <a:xfrm>
+            <a:off x="822960" y="5440680"/>
+            <a:ext cx="10515600" cy="457200"/>
+          </a:xfrm>
+          <a:prstGeom prst="rect">
+            <a:avLst/>
+          </a:prstGeom>
+          <a:noFill/>
+          <a:ln/>
+        </p:spPr>
+        <p:txBody>
+          <a:bodyPr wrap="square" lIns="0" tIns="0" rIns="0" bIns="0" rtlCol="0" anchor="ctr"/>
+          <a:lstStyle/>
+          <a:p>
+            <a:pPr indent="0" marL="0">
+              <a:buNone/>
+            </a:pPr>
+            <a:r>
+              <a:rPr lang="en-US" sz="1600" b="1" dirty="0">
+                <a:solidFill>
+                  <a:srgbClr val="02C39A"/>
+                </a:solidFill>
+                <a:latin typeface="Calibri" pitchFamily="34" charset="0"/>
+                <a:ea typeface="Calibri" pitchFamily="34" charset="-122"/>
+                <a:cs typeface="Calibri" pitchFamily="34" charset="-120"/>
+              </a:rPr>
+              <a:t>Aim for at least 8 stories across different parts of the system.</a:t>
+            </a:r>
+            <a:endParaRPr lang="en-US" sz="1600" dirty="0"/>
+          </a:p>
+        </p:txBody>
+      </p:sp>
+    </p:spTree>
+  </p:cSld>
+  <p:clrMapOvr>
+    <a:masterClrMapping/>
+  </p:clrMapOvr>
+</p:sld>
+</file>
+
+<file path=ppt/slides/slide11.xml><?xml version="1.0" encoding="utf-8"?>
+<p:sld xmlns:a="http://schemas.openxmlformats.org/drawingml/2006/main" xmlns:r="http://schemas.openxmlformats.org/officeDocument/2006/relationships" xmlns:p="http://schemas.openxmlformats.org/presentationml/2006/main">
+  <p:cSld name="Slide 11">
+    <p:bg>
+      <p:bgPr>
+        <a:solidFill>
           <a:srgbClr val="FFFFFF"/>
         </a:solidFill>
       </p:bgPr>
@@ -2910,9 +3701,478 @@
 </p:sld>
 </file>
 
-<file path=ppt/slides/slide11.xml><?xml version="1.0" encoding="utf-8"?>
+<file path=ppt/slides/slide12.xml><?xml version="1.0" encoding="utf-8"?>
 <p:sld xmlns:a="http://schemas.openxmlformats.org/drawingml/2006/main" xmlns:r="http://schemas.openxmlformats.org/officeDocument/2006/relationships" xmlns:p="http://schemas.openxmlformats.org/presentationml/2006/main">
-  <p:cSld name="Slide 11">
+  <p:cSld name="Slide 12">
+    <p:bg>
+      <p:bgPr>
+        <a:solidFill>
+          <a:srgbClr val="FFFFFF"/>
+        </a:solidFill>
+      </p:bgPr>
+    </p:bg>
+    <p:spTree>
+      <p:nvGrpSpPr>
+        <p:cNvPr id="1" name=""/>
+        <p:cNvGrpSpPr/>
+        <p:nvPr/>
+      </p:nvGrpSpPr>
+      <p:grpSpPr>
+        <a:xfrm>
+          <a:off x="0" y="0"/>
+          <a:ext cx="0" cy="0"/>
+          <a:chOff x="0" y="0"/>
+          <a:chExt cx="0" cy="0"/>
+        </a:xfrm>
+      </p:grpSpPr>
+      <p:sp>
+        <p:nvSpPr>
+          <p:cNvPr id="2" name="Text 0"/>
+          <p:cNvSpPr/>
+          <p:nvPr/>
+        </p:nvSpPr>
+        <p:spPr>
+          <a:xfrm>
+            <a:off x="566928" y="182880"/>
+            <a:ext cx="10972800" cy="274320"/>
+          </a:xfrm>
+          <a:prstGeom prst="rect">
+            <a:avLst/>
+          </a:prstGeom>
+          <a:noFill/>
+          <a:ln/>
+        </p:spPr>
+        <p:txBody>
+          <a:bodyPr wrap="square" lIns="0" tIns="0" rIns="0" bIns="0" rtlCol="0" anchor="ctr"/>
+          <a:lstStyle/>
+          <a:p>
+            <a:pPr algn="l" indent="0" marL="0">
+              <a:buNone/>
+            </a:pPr>
+            <a:r>
+              <a:rPr lang="en-US" sz="1300" b="1" spc="300" kern="0" dirty="0">
+                <a:solidFill>
+                  <a:srgbClr val="028090"/>
+                </a:solidFill>
+                <a:latin typeface="Calibri" pitchFamily="34" charset="0"/>
+                <a:ea typeface="Calibri" pitchFamily="34" charset="-122"/>
+                <a:cs typeface="Calibri" pitchFamily="34" charset="-120"/>
+              </a:rPr>
+              <a:t>Q2 REFERENCE · LEAVE THIS UP WHILE YOU WORK</a:t>
+            </a:r>
+            <a:endParaRPr lang="en-US" sz="1300" dirty="0"/>
+          </a:p>
+        </p:txBody>
+      </p:sp>
+      <p:sp>
+        <p:nvSpPr>
+          <p:cNvPr id="3" name="Text 1"/>
+          <p:cNvSpPr/>
+          <p:nvPr/>
+        </p:nvSpPr>
+        <p:spPr>
+          <a:xfrm>
+            <a:off x="548640" y="411480"/>
+            <a:ext cx="11064240" cy="822960"/>
+          </a:xfrm>
+          <a:prstGeom prst="rect">
+            <a:avLst/>
+          </a:prstGeom>
+          <a:noFill/>
+          <a:ln/>
+        </p:spPr>
+        <p:txBody>
+          <a:bodyPr wrap="square" lIns="0" tIns="0" rIns="0" bIns="0" rtlCol="0" anchor="ctr"/>
+          <a:lstStyle/>
+          <a:p>
+            <a:pPr algn="l" indent="0" marL="0">
+              <a:buNone/>
+            </a:pPr>
+            <a:r>
+              <a:rPr lang="en-US" sz="3400" b="1" dirty="0">
+                <a:solidFill>
+                  <a:srgbClr val="065A82"/>
+                </a:solidFill>
+                <a:latin typeface="Cambria" pitchFamily="34" charset="0"/>
+                <a:ea typeface="Cambria" pitchFamily="34" charset="-122"/>
+                <a:cs typeface="Cambria" pitchFamily="34" charset="-120"/>
+              </a:rPr>
+              <a:t>Q2 · Example &amp; what the FDA expects</a:t>
+            </a:r>
+            <a:endParaRPr lang="en-US" sz="3400" dirty="0"/>
+          </a:p>
+        </p:txBody>
+      </p:sp>
+      <p:sp>
+        <p:nvSpPr>
+          <p:cNvPr id="4" name="Shape 2"/>
+          <p:cNvSpPr/>
+          <p:nvPr/>
+        </p:nvSpPr>
+        <p:spPr>
+          <a:xfrm>
+            <a:off x="548640" y="1536192"/>
+            <a:ext cx="5486400" cy="4709160"/>
+          </a:xfrm>
+          <a:prstGeom prst="roundRect">
+            <a:avLst>
+              <a:gd name="adj" fmla="val 1553"/>
+            </a:avLst>
+          </a:prstGeom>
+          <a:solidFill>
+            <a:srgbClr val="EAF3F5"/>
+          </a:solidFill>
+          <a:ln/>
+        </p:spPr>
+      </p:sp>
+      <p:sp>
+        <p:nvSpPr>
+          <p:cNvPr id="5" name="Text 3"/>
+          <p:cNvSpPr/>
+          <p:nvPr/>
+        </p:nvSpPr>
+        <p:spPr>
+          <a:xfrm>
+            <a:off x="822960" y="1755648"/>
+            <a:ext cx="4937760" cy="457200"/>
+          </a:xfrm>
+          <a:prstGeom prst="rect">
+            <a:avLst/>
+          </a:prstGeom>
+          <a:noFill/>
+          <a:ln/>
+        </p:spPr>
+        <p:txBody>
+          <a:bodyPr wrap="square" lIns="0" tIns="0" rIns="0" bIns="0" rtlCol="0" anchor="ctr"/>
+          <a:lstStyle/>
+          <a:p>
+            <a:pPr indent="0" marL="0">
+              <a:buNone/>
+            </a:pPr>
+            <a:r>
+              <a:rPr lang="en-US" sz="1800" b="1" dirty="0">
+                <a:solidFill>
+                  <a:srgbClr val="028090"/>
+                </a:solidFill>
+                <a:latin typeface="Cambria" pitchFamily="34" charset="0"/>
+                <a:ea typeface="Cambria" pitchFamily="34" charset="-122"/>
+                <a:cs typeface="Cambria" pitchFamily="34" charset="-120"/>
+              </a:rPr>
+              <a:t>Worked example — a scored threat</a:t>
+            </a:r>
+            <a:endParaRPr lang="en-US" sz="1800" dirty="0"/>
+          </a:p>
+        </p:txBody>
+      </p:sp>
+      <p:sp>
+        <p:nvSpPr>
+          <p:cNvPr id="6" name="Text 4"/>
+          <p:cNvSpPr/>
+          <p:nvPr/>
+        </p:nvSpPr>
+        <p:spPr>
+          <a:xfrm>
+            <a:off x="841248" y="2359152"/>
+            <a:ext cx="4919472" cy="3657600"/>
+          </a:xfrm>
+          <a:prstGeom prst="rect">
+            <a:avLst/>
+          </a:prstGeom>
+          <a:noFill/>
+          <a:ln/>
+        </p:spPr>
+        <p:txBody>
+          <a:bodyPr wrap="square" lIns="0" tIns="0" rIns="0" bIns="0" rtlCol="0" anchor="t"/>
+          <a:lstStyle/>
+          <a:p>
+            <a:pPr marL="203200" indent="-203200">
+              <a:spcAft>
+                <a:spcPts val="1000"/>
+              </a:spcAft>
+              <a:buSzPct val="100000"/>
+              <a:buChar char="•"/>
+            </a:pPr>
+            <a:r>
+              <a:rPr lang="en-US" sz="1350" dirty="0">
+                <a:solidFill>
+                  <a:srgbClr val="172A38"/>
+                </a:solidFill>
+                <a:latin typeface="Calibri" pitchFamily="34" charset="0"/>
+                <a:ea typeface="Calibri" pitchFamily="34" charset="-122"/>
+                <a:cs typeface="Calibri" pitchFamily="34" charset="-120"/>
+              </a:rPr>
+              <a:t>T-04 (Elevation of privilege): brute-force the no-MFA admin console on the hospital LAN → full workstation control</a:t>
+            </a:r>
+            <a:endParaRPr lang="en-US" sz="1350" dirty="0"/>
+          </a:p>
+          <a:p>
+            <a:pPr marL="203200" indent="-203200">
+              <a:spcAft>
+                <a:spcPts val="1000"/>
+              </a:spcAft>
+              <a:buSzPct val="100000"/>
+              <a:buChar char="•"/>
+            </a:pPr>
+            <a:r>
+              <a:rPr lang="en-US" sz="1350" dirty="0">
+                <a:solidFill>
+                  <a:srgbClr val="172A38"/>
+                </a:solidFill>
+                <a:latin typeface="Calibri" pitchFamily="34" charset="0"/>
+                <a:ea typeface="Calibri" pitchFamily="34" charset="-122"/>
+                <a:cs typeface="Calibri" pitchFamily="34" charset="-120"/>
+              </a:rPr>
+              <a:t>Likelihood 3 (no MFA, no rate-limit) × Impact 3 (full compromise) = 9</a:t>
+            </a:r>
+            <a:endParaRPr lang="en-US" sz="1350" dirty="0"/>
+          </a:p>
+          <a:p>
+            <a:pPr marL="203200" indent="-203200">
+              <a:spcAft>
+                <a:spcPts val="1000"/>
+              </a:spcAft>
+              <a:buSzPct val="100000"/>
+              <a:buChar char="•"/>
+            </a:pPr>
+            <a:r>
+              <a:rPr lang="en-US" sz="1350" dirty="0">
+                <a:solidFill>
+                  <a:srgbClr val="172A38"/>
+                </a:solidFill>
+                <a:latin typeface="Calibri" pitchFamily="34" charset="0"/>
+                <a:ea typeface="Calibri" pitchFamily="34" charset="-122"/>
+                <a:cs typeface="Calibri" pitchFamily="34" charset="-120"/>
+              </a:rPr>
+              <a:t>Patient-safety override: Yes → High</a:t>
+            </a:r>
+            <a:endParaRPr lang="en-US" sz="1350" dirty="0"/>
+          </a:p>
+          <a:p>
+            <a:pPr marL="203200" indent="-203200">
+              <a:spcAft>
+                <a:spcPts val="1000"/>
+              </a:spcAft>
+              <a:buSzPct val="100000"/>
+              <a:buChar char="•"/>
+            </a:pPr>
+            <a:r>
+              <a:rPr lang="en-US" sz="1350" dirty="0">
+                <a:solidFill>
+                  <a:srgbClr val="172A38"/>
+                </a:solidFill>
+                <a:latin typeface="Calibri" pitchFamily="34" charset="0"/>
+                <a:ea typeface="Calibri" pitchFamily="34" charset="-122"/>
+                <a:cs typeface="Calibri" pitchFamily="34" charset="-120"/>
+              </a:rPr>
+              <a:t>Rationale is about exploitability — how feasible — not the odds of an attack</a:t>
+            </a:r>
+            <a:endParaRPr lang="en-US" sz="1350" dirty="0"/>
+          </a:p>
+        </p:txBody>
+      </p:sp>
+      <p:sp>
+        <p:nvSpPr>
+          <p:cNvPr id="7" name="Shape 5"/>
+          <p:cNvSpPr/>
+          <p:nvPr/>
+        </p:nvSpPr>
+        <p:spPr>
+          <a:xfrm>
+            <a:off x="6355080" y="1536192"/>
+            <a:ext cx="5285232" cy="4709160"/>
+          </a:xfrm>
+          <a:prstGeom prst="roundRect">
+            <a:avLst>
+              <a:gd name="adj" fmla="val 1553"/>
+            </a:avLst>
+          </a:prstGeom>
+          <a:solidFill>
+            <a:srgbClr val="F0F5F9"/>
+          </a:solidFill>
+          <a:ln w="15875">
+            <a:solidFill>
+              <a:srgbClr val="065A82"/>
+            </a:solidFill>
+            <a:prstDash val="solid"/>
+          </a:ln>
+        </p:spPr>
+      </p:sp>
+      <p:sp>
+        <p:nvSpPr>
+          <p:cNvPr id="8" name="Shape 6"/>
+          <p:cNvSpPr/>
+          <p:nvPr/>
+        </p:nvSpPr>
+        <p:spPr>
+          <a:xfrm>
+            <a:off x="6629400" y="1783080"/>
+            <a:ext cx="384048" cy="384048"/>
+          </a:xfrm>
+          <a:prstGeom prst="ellipse">
+            <a:avLst/>
+          </a:prstGeom>
+          <a:solidFill>
+            <a:srgbClr val="065A82"/>
+          </a:solidFill>
+          <a:ln/>
+        </p:spPr>
+      </p:sp>
+      <p:sp>
+        <p:nvSpPr>
+          <p:cNvPr id="9" name="Text 7"/>
+          <p:cNvSpPr/>
+          <p:nvPr/>
+        </p:nvSpPr>
+        <p:spPr>
+          <a:xfrm>
+            <a:off x="7132320" y="1755648"/>
+            <a:ext cx="4279392" cy="411480"/>
+          </a:xfrm>
+          <a:prstGeom prst="rect">
+            <a:avLst/>
+          </a:prstGeom>
+          <a:noFill/>
+          <a:ln/>
+        </p:spPr>
+        <p:txBody>
+          <a:bodyPr wrap="square" lIns="0" tIns="0" rIns="0" bIns="0" rtlCol="0" anchor="ctr"/>
+          <a:lstStyle/>
+          <a:p>
+            <a:pPr indent="0" marL="0">
+              <a:buNone/>
+            </a:pPr>
+            <a:r>
+              <a:rPr lang="en-US" sz="1800" b="1" dirty="0">
+                <a:solidFill>
+                  <a:srgbClr val="065A82"/>
+                </a:solidFill>
+                <a:latin typeface="Cambria" pitchFamily="34" charset="0"/>
+                <a:ea typeface="Cambria" pitchFamily="34" charset="-122"/>
+                <a:cs typeface="Cambria" pitchFamily="34" charset="-120"/>
+              </a:rPr>
+              <a:t>What the FDA expects</a:t>
+            </a:r>
+            <a:endParaRPr lang="en-US" sz="1800" dirty="0"/>
+          </a:p>
+        </p:txBody>
+      </p:sp>
+      <p:sp>
+        <p:nvSpPr>
+          <p:cNvPr id="10" name="Text 8"/>
+          <p:cNvSpPr/>
+          <p:nvPr/>
+        </p:nvSpPr>
+        <p:spPr>
+          <a:xfrm>
+            <a:off x="6647688" y="2404872"/>
+            <a:ext cx="4700016" cy="3611880"/>
+          </a:xfrm>
+          <a:prstGeom prst="rect">
+            <a:avLst/>
+          </a:prstGeom>
+          <a:noFill/>
+          <a:ln/>
+        </p:spPr>
+        <p:txBody>
+          <a:bodyPr wrap="square" lIns="0" tIns="0" rIns="0" bIns="0" rtlCol="0" anchor="t"/>
+          <a:lstStyle/>
+          <a:p>
+            <a:pPr marL="203200" indent="-203200">
+              <a:spcAft>
+                <a:spcPts val="1100"/>
+              </a:spcAft>
+              <a:buSzPct val="100000"/>
+              <a:buChar char="•"/>
+            </a:pPr>
+            <a:r>
+              <a:rPr lang="en-US" sz="1350" dirty="0">
+                <a:solidFill>
+                  <a:srgbClr val="172A38"/>
+                </a:solidFill>
+                <a:latin typeface="Calibri" pitchFamily="34" charset="0"/>
+                <a:ea typeface="Calibri" pitchFamily="34" charset="-122"/>
+                <a:cs typeface="Calibri" pitchFamily="34" charset="-120"/>
+              </a:rPr>
+              <a:t>Judge security risk on exploitability, not probability — not the ISO 14971 approach</a:t>
+            </a:r>
+            <a:endParaRPr lang="en-US" sz="1350" dirty="0"/>
+          </a:p>
+          <a:p>
+            <a:pPr marL="203200" indent="-203200">
+              <a:spcAft>
+                <a:spcPts val="1100"/>
+              </a:spcAft>
+              <a:buSzPct val="100000"/>
+              <a:buChar char="•"/>
+            </a:pPr>
+            <a:r>
+              <a:rPr lang="en-US" sz="1350" dirty="0">
+                <a:solidFill>
+                  <a:srgbClr val="172A38"/>
+                </a:solidFill>
+                <a:latin typeface="Calibri" pitchFamily="34" charset="0"/>
+                <a:ea typeface="Calibri" pitchFamily="34" charset="-122"/>
+                <a:cs typeface="Calibri" pitchFamily="34" charset="-120"/>
+              </a:rPr>
+              <a:t>Keep a severity-of-patient-harm axis → a controlled / uncontrolled call</a:t>
+            </a:r>
+            <a:endParaRPr lang="en-US" sz="1350" dirty="0"/>
+          </a:p>
+          <a:p>
+            <a:pPr marL="203200" indent="-203200">
+              <a:spcAft>
+                <a:spcPts val="1100"/>
+              </a:spcAft>
+              <a:buSzPct val="100000"/>
+              <a:buChar char="•"/>
+            </a:pPr>
+            <a:r>
+              <a:rPr lang="en-US" sz="1350" dirty="0">
+                <a:solidFill>
+                  <a:srgbClr val="172A38"/>
+                </a:solidFill>
+                <a:latin typeface="Calibri" pitchFamily="34" charset="0"/>
+                <a:ea typeface="Calibri" pitchFamily="34" charset="-122"/>
+                <a:cs typeface="Calibri" pitchFamily="34" charset="-120"/>
+              </a:rPr>
+              <a:t>A patient-safety override can outrank the numeric score</a:t>
+            </a:r>
+            <a:endParaRPr lang="en-US" sz="1350" dirty="0"/>
+          </a:p>
+          <a:p>
+            <a:pPr marL="203200" indent="-203200">
+              <a:spcAft>
+                <a:spcPts val="1100"/>
+              </a:spcAft>
+              <a:buSzPct val="100000"/>
+              <a:buChar char="•"/>
+            </a:pPr>
+            <a:r>
+              <a:rPr lang="en-US" sz="1350" dirty="0">
+                <a:solidFill>
+                  <a:srgbClr val="172A38"/>
+                </a:solidFill>
+                <a:latin typeface="Calibri" pitchFamily="34" charset="0"/>
+                <a:ea typeface="Calibri" pitchFamily="34" charset="-122"/>
+                <a:cs typeface="Calibri" pitchFamily="34" charset="-120"/>
+              </a:rPr>
+              <a:t>Cybersecurity risk scales independently of software / safety risk</a:t>
+            </a:r>
+            <a:endParaRPr lang="en-US" sz="1350" dirty="0"/>
+          </a:p>
+        </p:txBody>
+      </p:sp>
+    </p:spTree>
+  </p:cSld>
+  <p:clrMapOvr>
+    <a:masterClrMapping/>
+  </p:clrMapOvr>
+</p:sld>
+</file>
+
+<file path=ppt/slides/slide13.xml><?xml version="1.0" encoding="utf-8"?>
+<p:sld xmlns:a="http://schemas.openxmlformats.org/drawingml/2006/main" xmlns:r="http://schemas.openxmlformats.org/officeDocument/2006/relationships" xmlns:p="http://schemas.openxmlformats.org/presentationml/2006/main">
+  <p:cSld name="Slide 13">
     <p:bg>
       <p:bgPr>
         <a:solidFill>
@@ -3205,9 +4465,478 @@
 </p:sld>
 </file>
 
-<file path=ppt/slides/slide12.xml><?xml version="1.0" encoding="utf-8"?>
+<file path=ppt/slides/slide14.xml><?xml version="1.0" encoding="utf-8"?>
 <p:sld xmlns:a="http://schemas.openxmlformats.org/drawingml/2006/main" xmlns:r="http://schemas.openxmlformats.org/officeDocument/2006/relationships" xmlns:p="http://schemas.openxmlformats.org/presentationml/2006/main">
-  <p:cSld name="Slide 12">
+  <p:cSld name="Slide 14">
+    <p:bg>
+      <p:bgPr>
+        <a:solidFill>
+          <a:srgbClr val="FFFFFF"/>
+        </a:solidFill>
+      </p:bgPr>
+    </p:bg>
+    <p:spTree>
+      <p:nvGrpSpPr>
+        <p:cNvPr id="1" name=""/>
+        <p:cNvGrpSpPr/>
+        <p:nvPr/>
+      </p:nvGrpSpPr>
+      <p:grpSpPr>
+        <a:xfrm>
+          <a:off x="0" y="0"/>
+          <a:ext cx="0" cy="0"/>
+          <a:chOff x="0" y="0"/>
+          <a:chExt cx="0" cy="0"/>
+        </a:xfrm>
+      </p:grpSpPr>
+      <p:sp>
+        <p:nvSpPr>
+          <p:cNvPr id="2" name="Text 0"/>
+          <p:cNvSpPr/>
+          <p:nvPr/>
+        </p:nvSpPr>
+        <p:spPr>
+          <a:xfrm>
+            <a:off x="566928" y="182880"/>
+            <a:ext cx="10972800" cy="274320"/>
+          </a:xfrm>
+          <a:prstGeom prst="rect">
+            <a:avLst/>
+          </a:prstGeom>
+          <a:noFill/>
+          <a:ln/>
+        </p:spPr>
+        <p:txBody>
+          <a:bodyPr wrap="square" lIns="0" tIns="0" rIns="0" bIns="0" rtlCol="0" anchor="ctr"/>
+          <a:lstStyle/>
+          <a:p>
+            <a:pPr algn="l" indent="0" marL="0">
+              <a:buNone/>
+            </a:pPr>
+            <a:r>
+              <a:rPr lang="en-US" sz="1300" b="1" spc="300" kern="0" dirty="0">
+                <a:solidFill>
+                  <a:srgbClr val="028090"/>
+                </a:solidFill>
+                <a:latin typeface="Calibri" pitchFamily="34" charset="0"/>
+                <a:ea typeface="Calibri" pitchFamily="34" charset="-122"/>
+                <a:cs typeface="Calibri" pitchFamily="34" charset="-120"/>
+              </a:rPr>
+              <a:t>Q3 REFERENCE · LEAVE THIS UP WHILE YOU WORK</a:t>
+            </a:r>
+            <a:endParaRPr lang="en-US" sz="1300" dirty="0"/>
+          </a:p>
+        </p:txBody>
+      </p:sp>
+      <p:sp>
+        <p:nvSpPr>
+          <p:cNvPr id="3" name="Text 1"/>
+          <p:cNvSpPr/>
+          <p:nvPr/>
+        </p:nvSpPr>
+        <p:spPr>
+          <a:xfrm>
+            <a:off x="548640" y="411480"/>
+            <a:ext cx="11064240" cy="822960"/>
+          </a:xfrm>
+          <a:prstGeom prst="rect">
+            <a:avLst/>
+          </a:prstGeom>
+          <a:noFill/>
+          <a:ln/>
+        </p:spPr>
+        <p:txBody>
+          <a:bodyPr wrap="square" lIns="0" tIns="0" rIns="0" bIns="0" rtlCol="0" anchor="ctr"/>
+          <a:lstStyle/>
+          <a:p>
+            <a:pPr algn="l" indent="0" marL="0">
+              <a:buNone/>
+            </a:pPr>
+            <a:r>
+              <a:rPr lang="en-US" sz="3400" b="1" dirty="0">
+                <a:solidFill>
+                  <a:srgbClr val="065A82"/>
+                </a:solidFill>
+                <a:latin typeface="Cambria" pitchFamily="34" charset="0"/>
+                <a:ea typeface="Cambria" pitchFamily="34" charset="-122"/>
+                <a:cs typeface="Cambria" pitchFamily="34" charset="-120"/>
+              </a:rPr>
+              <a:t>Q3 · Example &amp; what the FDA expects</a:t>
+            </a:r>
+            <a:endParaRPr lang="en-US" sz="3400" dirty="0"/>
+          </a:p>
+        </p:txBody>
+      </p:sp>
+      <p:sp>
+        <p:nvSpPr>
+          <p:cNvPr id="4" name="Shape 2"/>
+          <p:cNvSpPr/>
+          <p:nvPr/>
+        </p:nvSpPr>
+        <p:spPr>
+          <a:xfrm>
+            <a:off x="548640" y="1536192"/>
+            <a:ext cx="5486400" cy="4709160"/>
+          </a:xfrm>
+          <a:prstGeom prst="roundRect">
+            <a:avLst>
+              <a:gd name="adj" fmla="val 1553"/>
+            </a:avLst>
+          </a:prstGeom>
+          <a:solidFill>
+            <a:srgbClr val="EAF3F5"/>
+          </a:solidFill>
+          <a:ln/>
+        </p:spPr>
+      </p:sp>
+      <p:sp>
+        <p:nvSpPr>
+          <p:cNvPr id="5" name="Text 3"/>
+          <p:cNvSpPr/>
+          <p:nvPr/>
+        </p:nvSpPr>
+        <p:spPr>
+          <a:xfrm>
+            <a:off x="822960" y="1755648"/>
+            <a:ext cx="4937760" cy="457200"/>
+          </a:xfrm>
+          <a:prstGeom prst="rect">
+            <a:avLst/>
+          </a:prstGeom>
+          <a:noFill/>
+          <a:ln/>
+        </p:spPr>
+        <p:txBody>
+          <a:bodyPr wrap="square" lIns="0" tIns="0" rIns="0" bIns="0" rtlCol="0" anchor="ctr"/>
+          <a:lstStyle/>
+          <a:p>
+            <a:pPr indent="0" marL="0">
+              <a:buNone/>
+            </a:pPr>
+            <a:r>
+              <a:rPr lang="en-US" sz="1800" b="1" dirty="0">
+                <a:solidFill>
+                  <a:srgbClr val="028090"/>
+                </a:solidFill>
+                <a:latin typeface="Cambria" pitchFamily="34" charset="0"/>
+                <a:ea typeface="Cambria" pitchFamily="34" charset="-122"/>
+                <a:cs typeface="Cambria" pitchFamily="34" charset="-120"/>
+              </a:rPr>
+              <a:t>Worked example — a mitigation</a:t>
+            </a:r>
+            <a:endParaRPr lang="en-US" sz="1800" dirty="0"/>
+          </a:p>
+        </p:txBody>
+      </p:sp>
+      <p:sp>
+        <p:nvSpPr>
+          <p:cNvPr id="6" name="Text 4"/>
+          <p:cNvSpPr/>
+          <p:nvPr/>
+        </p:nvSpPr>
+        <p:spPr>
+          <a:xfrm>
+            <a:off x="841248" y="2359152"/>
+            <a:ext cx="4919472" cy="3657600"/>
+          </a:xfrm>
+          <a:prstGeom prst="rect">
+            <a:avLst/>
+          </a:prstGeom>
+          <a:noFill/>
+          <a:ln/>
+        </p:spPr>
+        <p:txBody>
+          <a:bodyPr wrap="square" lIns="0" tIns="0" rIns="0" bIns="0" rtlCol="0" anchor="t"/>
+          <a:lstStyle/>
+          <a:p>
+            <a:pPr marL="203200" indent="-203200">
+              <a:spcAft>
+                <a:spcPts val="1000"/>
+              </a:spcAft>
+              <a:buSzPct val="100000"/>
+              <a:buChar char="•"/>
+            </a:pPr>
+            <a:r>
+              <a:rPr lang="en-US" sz="1350" dirty="0">
+                <a:solidFill>
+                  <a:srgbClr val="172A38"/>
+                </a:solidFill>
+                <a:latin typeface="Calibri" pitchFamily="34" charset="0"/>
+                <a:ea typeface="Calibri" pitchFamily="34" charset="-122"/>
+                <a:cs typeface="Calibri" pitchFamily="34" charset="-120"/>
+              </a:rPr>
+              <a:t>M-01 addresses T-04 &amp; T-07 — type: Preventive</a:t>
+            </a:r>
+            <a:endParaRPr lang="en-US" sz="1350" dirty="0"/>
+          </a:p>
+          <a:p>
+            <a:pPr marL="203200" indent="-203200">
+              <a:spcAft>
+                <a:spcPts val="1000"/>
+              </a:spcAft>
+              <a:buSzPct val="100000"/>
+              <a:buChar char="•"/>
+            </a:pPr>
+            <a:r>
+              <a:rPr lang="en-US" sz="1350" dirty="0">
+                <a:solidFill>
+                  <a:srgbClr val="172A38"/>
+                </a:solidFill>
+                <a:latin typeface="Calibri" pitchFamily="34" charset="0"/>
+                <a:ea typeface="Calibri" pitchFamily="34" charset="-122"/>
+                <a:cs typeface="Calibri" pitchFamily="34" charset="-120"/>
+              </a:rPr>
+              <a:t>Enforce TOTP MFA on the admin console; replace the shared support credential with per-engineer PKI certs; rate-limit logins</a:t>
+            </a:r>
+            <a:endParaRPr lang="en-US" sz="1350" dirty="0"/>
+          </a:p>
+          <a:p>
+            <a:pPr marL="203200" indent="-203200">
+              <a:spcAft>
+                <a:spcPts val="1000"/>
+              </a:spcAft>
+              <a:buSzPct val="100000"/>
+              <a:buChar char="•"/>
+            </a:pPr>
+            <a:r>
+              <a:rPr lang="en-US" sz="1350" dirty="0">
+                <a:solidFill>
+                  <a:srgbClr val="172A38"/>
+                </a:solidFill>
+                <a:latin typeface="Calibri" pitchFamily="34" charset="0"/>
+                <a:ea typeface="Calibri" pitchFamily="34" charset="-122"/>
+                <a:cs typeface="Calibri" pitchFamily="34" charset="-120"/>
+              </a:rPr>
+              <a:t>Residual risk: credential theft still possible if the device is already compromised</a:t>
+            </a:r>
+            <a:endParaRPr lang="en-US" sz="1350" dirty="0"/>
+          </a:p>
+          <a:p>
+            <a:pPr marL="203200" indent="-203200">
+              <a:spcAft>
+                <a:spcPts val="1000"/>
+              </a:spcAft>
+              <a:buSzPct val="100000"/>
+              <a:buChar char="•"/>
+            </a:pPr>
+            <a:r>
+              <a:rPr lang="en-US" sz="1350" dirty="0">
+                <a:solidFill>
+                  <a:srgbClr val="172A38"/>
+                </a:solidFill>
+                <a:latin typeface="Calibri" pitchFamily="34" charset="0"/>
+                <a:ea typeface="Calibri" pitchFamily="34" charset="-122"/>
+                <a:cs typeface="Calibri" pitchFamily="34" charset="-120"/>
+              </a:rPr>
+              <a:t>Regulatory note: software change only — likely no new clearance</a:t>
+            </a:r>
+            <a:endParaRPr lang="en-US" sz="1350" dirty="0"/>
+          </a:p>
+        </p:txBody>
+      </p:sp>
+      <p:sp>
+        <p:nvSpPr>
+          <p:cNvPr id="7" name="Shape 5"/>
+          <p:cNvSpPr/>
+          <p:nvPr/>
+        </p:nvSpPr>
+        <p:spPr>
+          <a:xfrm>
+            <a:off x="6355080" y="1536192"/>
+            <a:ext cx="5285232" cy="4709160"/>
+          </a:xfrm>
+          <a:prstGeom prst="roundRect">
+            <a:avLst>
+              <a:gd name="adj" fmla="val 1553"/>
+            </a:avLst>
+          </a:prstGeom>
+          <a:solidFill>
+            <a:srgbClr val="F0F5F9"/>
+          </a:solidFill>
+          <a:ln w="15875">
+            <a:solidFill>
+              <a:srgbClr val="065A82"/>
+            </a:solidFill>
+            <a:prstDash val="solid"/>
+          </a:ln>
+        </p:spPr>
+      </p:sp>
+      <p:sp>
+        <p:nvSpPr>
+          <p:cNvPr id="8" name="Shape 6"/>
+          <p:cNvSpPr/>
+          <p:nvPr/>
+        </p:nvSpPr>
+        <p:spPr>
+          <a:xfrm>
+            <a:off x="6629400" y="1783080"/>
+            <a:ext cx="384048" cy="384048"/>
+          </a:xfrm>
+          <a:prstGeom prst="ellipse">
+            <a:avLst/>
+          </a:prstGeom>
+          <a:solidFill>
+            <a:srgbClr val="065A82"/>
+          </a:solidFill>
+          <a:ln/>
+        </p:spPr>
+      </p:sp>
+      <p:sp>
+        <p:nvSpPr>
+          <p:cNvPr id="9" name="Text 7"/>
+          <p:cNvSpPr/>
+          <p:nvPr/>
+        </p:nvSpPr>
+        <p:spPr>
+          <a:xfrm>
+            <a:off x="7132320" y="1755648"/>
+            <a:ext cx="4279392" cy="411480"/>
+          </a:xfrm>
+          <a:prstGeom prst="rect">
+            <a:avLst/>
+          </a:prstGeom>
+          <a:noFill/>
+          <a:ln/>
+        </p:spPr>
+        <p:txBody>
+          <a:bodyPr wrap="square" lIns="0" tIns="0" rIns="0" bIns="0" rtlCol="0" anchor="ctr"/>
+          <a:lstStyle/>
+          <a:p>
+            <a:pPr indent="0" marL="0">
+              <a:buNone/>
+            </a:pPr>
+            <a:r>
+              <a:rPr lang="en-US" sz="1800" b="1" dirty="0">
+                <a:solidFill>
+                  <a:srgbClr val="065A82"/>
+                </a:solidFill>
+                <a:latin typeface="Cambria" pitchFamily="34" charset="0"/>
+                <a:ea typeface="Cambria" pitchFamily="34" charset="-122"/>
+                <a:cs typeface="Cambria" pitchFamily="34" charset="-120"/>
+              </a:rPr>
+              <a:t>What the FDA expects</a:t>
+            </a:r>
+            <a:endParaRPr lang="en-US" sz="1800" dirty="0"/>
+          </a:p>
+        </p:txBody>
+      </p:sp>
+      <p:sp>
+        <p:nvSpPr>
+          <p:cNvPr id="10" name="Text 8"/>
+          <p:cNvSpPr/>
+          <p:nvPr/>
+        </p:nvSpPr>
+        <p:spPr>
+          <a:xfrm>
+            <a:off x="6647688" y="2404872"/>
+            <a:ext cx="4700016" cy="3611880"/>
+          </a:xfrm>
+          <a:prstGeom prst="rect">
+            <a:avLst/>
+          </a:prstGeom>
+          <a:noFill/>
+          <a:ln/>
+        </p:spPr>
+        <p:txBody>
+          <a:bodyPr wrap="square" lIns="0" tIns="0" rIns="0" bIns="0" rtlCol="0" anchor="t"/>
+          <a:lstStyle/>
+          <a:p>
+            <a:pPr marL="203200" indent="-203200">
+              <a:spcAft>
+                <a:spcPts val="1100"/>
+              </a:spcAft>
+              <a:buSzPct val="100000"/>
+              <a:buChar char="•"/>
+            </a:pPr>
+            <a:r>
+              <a:rPr lang="en-US" sz="1350" dirty="0">
+                <a:solidFill>
+                  <a:srgbClr val="172A38"/>
+                </a:solidFill>
+                <a:latin typeface="Calibri" pitchFamily="34" charset="0"/>
+                <a:ea typeface="Calibri" pitchFamily="34" charset="-122"/>
+                <a:cs typeface="Calibri" pitchFamily="34" charset="-120"/>
+              </a:rPr>
+              <a:t>The risk assessment consumes the threat model; controls are evaluated against threats (§V.A.2)</a:t>
+            </a:r>
+            <a:endParaRPr lang="en-US" sz="1350" dirty="0"/>
+          </a:p>
+          <a:p>
+            <a:pPr marL="203200" indent="-203200">
+              <a:spcAft>
+                <a:spcPts val="1100"/>
+              </a:spcAft>
+              <a:buSzPct val="100000"/>
+              <a:buChar char="•"/>
+            </a:pPr>
+            <a:r>
+              <a:rPr lang="en-US" sz="1350" dirty="0">
+                <a:solidFill>
+                  <a:srgbClr val="172A38"/>
+                </a:solidFill>
+                <a:latin typeface="Calibri" pitchFamily="34" charset="0"/>
+                <a:ea typeface="Calibri" pitchFamily="34" charset="-122"/>
+                <a:cs typeface="Calibri" pitchFamily="34" charset="-120"/>
+              </a:rPr>
+              <a:t>Record pre- and post-mitigation (residual) risk, with acceptance criteria</a:t>
+            </a:r>
+            <a:endParaRPr lang="en-US" sz="1350" dirty="0"/>
+          </a:p>
+          <a:p>
+            <a:pPr marL="203200" indent="-203200">
+              <a:spcAft>
+                <a:spcPts val="1100"/>
+              </a:spcAft>
+              <a:buSzPct val="100000"/>
+              <a:buChar char="•"/>
+            </a:pPr>
+            <a:r>
+              <a:rPr lang="en-US" sz="1350" dirty="0">
+                <a:solidFill>
+                  <a:srgbClr val="172A38"/>
+                </a:solidFill>
+                <a:latin typeface="Calibri" pitchFamily="34" charset="0"/>
+                <a:ea typeface="Calibri" pitchFamily="34" charset="-122"/>
+                <a:cs typeface="Calibri" pitchFamily="34" charset="-120"/>
+              </a:rPr>
+              <a:t>Don't let a security control create a new safety risk — the safety ↔ security interface</a:t>
+            </a:r>
+            <a:endParaRPr lang="en-US" sz="1350" dirty="0"/>
+          </a:p>
+          <a:p>
+            <a:pPr marL="203200" indent="-203200">
+              <a:spcAft>
+                <a:spcPts val="1100"/>
+              </a:spcAft>
+              <a:buSzPct val="100000"/>
+              <a:buChar char="•"/>
+            </a:pPr>
+            <a:r>
+              <a:rPr lang="en-US" sz="1350" dirty="0">
+                <a:solidFill>
+                  <a:srgbClr val="172A38"/>
+                </a:solidFill>
+                <a:latin typeface="Calibri" pitchFamily="34" charset="0"/>
+                <a:ea typeface="Calibri" pitchFamily="34" charset="-122"/>
+                <a:cs typeface="Calibri" pitchFamily="34" charset="-120"/>
+              </a:rPr>
+              <a:t>Document the scoring method, not just the numbers</a:t>
+            </a:r>
+            <a:endParaRPr lang="en-US" sz="1350" dirty="0"/>
+          </a:p>
+        </p:txBody>
+      </p:sp>
+    </p:spTree>
+  </p:cSld>
+  <p:clrMapOvr>
+    <a:masterClrMapping/>
+  </p:clrMapOvr>
+</p:sld>
+</file>
+
+<file path=ppt/slides/slide15.xml><?xml version="1.0" encoding="utf-8"?>
+<p:sld xmlns:a="http://schemas.openxmlformats.org/drawingml/2006/main" xmlns:r="http://schemas.openxmlformats.org/officeDocument/2006/relationships" xmlns:p="http://schemas.openxmlformats.org/presentationml/2006/main">
+  <p:cSld name="Slide 15">
     <p:bg>
       <p:bgPr>
         <a:solidFill>
@@ -3500,9 +5229,9 @@
 </p:sld>
 </file>
 
-<file path=ppt/slides/slide13.xml><?xml version="1.0" encoding="utf-8"?>
+<file path=ppt/slides/slide16.xml><?xml version="1.0" encoding="utf-8"?>
 <p:sld xmlns:a="http://schemas.openxmlformats.org/drawingml/2006/main" xmlns:r="http://schemas.openxmlformats.org/officeDocument/2006/relationships" xmlns:p="http://schemas.openxmlformats.org/presentationml/2006/main">
-  <p:cSld name="Slide 13">
+  <p:cSld name="Slide 16">
     <p:bg>
       <p:bgPr>
         <a:solidFill>
@@ -3557,6 +5286,475 @@
                 <a:ea typeface="Calibri" pitchFamily="34" charset="-122"/>
                 <a:cs typeface="Calibri" pitchFamily="34" charset="-120"/>
               </a:rPr>
+              <a:t>Q4 REFERENCE · LEAVE THIS UP WHILE YOU WORK</a:t>
+            </a:r>
+            <a:endParaRPr lang="en-US" sz="1300" dirty="0"/>
+          </a:p>
+        </p:txBody>
+      </p:sp>
+      <p:sp>
+        <p:nvSpPr>
+          <p:cNvPr id="3" name="Text 1"/>
+          <p:cNvSpPr/>
+          <p:nvPr/>
+        </p:nvSpPr>
+        <p:spPr>
+          <a:xfrm>
+            <a:off x="548640" y="411480"/>
+            <a:ext cx="11064240" cy="822960"/>
+          </a:xfrm>
+          <a:prstGeom prst="rect">
+            <a:avLst/>
+          </a:prstGeom>
+          <a:noFill/>
+          <a:ln/>
+        </p:spPr>
+        <p:txBody>
+          <a:bodyPr wrap="square" lIns="0" tIns="0" rIns="0" bIns="0" rtlCol="0" anchor="ctr"/>
+          <a:lstStyle/>
+          <a:p>
+            <a:pPr algn="l" indent="0" marL="0">
+              <a:buNone/>
+            </a:pPr>
+            <a:r>
+              <a:rPr lang="en-US" sz="3400" b="1" dirty="0">
+                <a:solidFill>
+                  <a:srgbClr val="065A82"/>
+                </a:solidFill>
+                <a:latin typeface="Cambria" pitchFamily="34" charset="0"/>
+                <a:ea typeface="Cambria" pitchFamily="34" charset="-122"/>
+                <a:cs typeface="Cambria" pitchFamily="34" charset="-120"/>
+              </a:rPr>
+              <a:t>Q4 · Example &amp; what the FDA expects</a:t>
+            </a:r>
+            <a:endParaRPr lang="en-US" sz="3400" dirty="0"/>
+          </a:p>
+        </p:txBody>
+      </p:sp>
+      <p:sp>
+        <p:nvSpPr>
+          <p:cNvPr id="4" name="Shape 2"/>
+          <p:cNvSpPr/>
+          <p:nvPr/>
+        </p:nvSpPr>
+        <p:spPr>
+          <a:xfrm>
+            <a:off x="548640" y="1536192"/>
+            <a:ext cx="5486400" cy="4709160"/>
+          </a:xfrm>
+          <a:prstGeom prst="roundRect">
+            <a:avLst>
+              <a:gd name="adj" fmla="val 1553"/>
+            </a:avLst>
+          </a:prstGeom>
+          <a:solidFill>
+            <a:srgbClr val="EAF3F5"/>
+          </a:solidFill>
+          <a:ln/>
+        </p:spPr>
+      </p:sp>
+      <p:sp>
+        <p:nvSpPr>
+          <p:cNvPr id="5" name="Text 3"/>
+          <p:cNvSpPr/>
+          <p:nvPr/>
+        </p:nvSpPr>
+        <p:spPr>
+          <a:xfrm>
+            <a:off x="822960" y="1755648"/>
+            <a:ext cx="4937760" cy="457200"/>
+          </a:xfrm>
+          <a:prstGeom prst="rect">
+            <a:avLst/>
+          </a:prstGeom>
+          <a:noFill/>
+          <a:ln/>
+        </p:spPr>
+        <p:txBody>
+          <a:bodyPr wrap="square" lIns="0" tIns="0" rIns="0" bIns="0" rtlCol="0" anchor="ctr"/>
+          <a:lstStyle/>
+          <a:p>
+            <a:pPr indent="0" marL="0">
+              <a:buNone/>
+            </a:pPr>
+            <a:r>
+              <a:rPr lang="en-US" sz="1800" b="1" dirty="0">
+                <a:solidFill>
+                  <a:srgbClr val="028090"/>
+                </a:solidFill>
+                <a:latin typeface="Cambria" pitchFamily="34" charset="0"/>
+                <a:ea typeface="Cambria" pitchFamily="34" charset="-122"/>
+                <a:cs typeface="Cambria" pitchFamily="34" charset="-120"/>
+              </a:rPr>
+              <a:t>Worked example — review &amp; lifecycle</a:t>
+            </a:r>
+            <a:endParaRPr lang="en-US" sz="1800" dirty="0"/>
+          </a:p>
+        </p:txBody>
+      </p:sp>
+      <p:sp>
+        <p:nvSpPr>
+          <p:cNvPr id="6" name="Text 4"/>
+          <p:cNvSpPr/>
+          <p:nvPr/>
+        </p:nvSpPr>
+        <p:spPr>
+          <a:xfrm>
+            <a:off x="841248" y="2359152"/>
+            <a:ext cx="4919472" cy="3657600"/>
+          </a:xfrm>
+          <a:prstGeom prst="rect">
+            <a:avLst/>
+          </a:prstGeom>
+          <a:noFill/>
+          <a:ln/>
+        </p:spPr>
+        <p:txBody>
+          <a:bodyPr wrap="square" lIns="0" tIns="0" rIns="0" bIns="0" rtlCol="0" anchor="t"/>
+          <a:lstStyle/>
+          <a:p>
+            <a:pPr marL="203200" indent="-203200">
+              <a:spcAft>
+                <a:spcPts val="1000"/>
+              </a:spcAft>
+              <a:buSzPct val="100000"/>
+              <a:buChar char="•"/>
+            </a:pPr>
+            <a:r>
+              <a:rPr lang="en-US" sz="1350" dirty="0">
+                <a:solidFill>
+                  <a:srgbClr val="172A38"/>
+                </a:solidFill>
+                <a:latin typeface="Calibri" pitchFamily="34" charset="0"/>
+                <a:ea typeface="Calibri" pitchFamily="34" charset="-122"/>
+                <a:cs typeface="Calibri" pitchFamily="34" charset="-120"/>
+              </a:rPr>
+              <a:t>Top-3 risks named; most-surprising = T-09 (rogue insider alters the AI model)</a:t>
+            </a:r>
+            <a:endParaRPr lang="en-US" sz="1350" dirty="0"/>
+          </a:p>
+          <a:p>
+            <a:pPr marL="203200" indent="-203200">
+              <a:spcAft>
+                <a:spcPts val="1000"/>
+              </a:spcAft>
+              <a:buSzPct val="100000"/>
+              <a:buChar char="•"/>
+            </a:pPr>
+            <a:r>
+              <a:rPr lang="en-US" sz="1350" dirty="0">
+                <a:solidFill>
+                  <a:srgbClr val="172A38"/>
+                </a:solidFill>
+                <a:latin typeface="Calibri" pitchFamily="34" charset="0"/>
+                <a:ea typeface="Calibri" pitchFamily="34" charset="-122"/>
+                <a:cs typeface="Calibri" pitchFamily="34" charset="-120"/>
+              </a:rPr>
+              <a:t>Hardest trade-off: fixing T-01 properly needs secure boot → a new 510(k)</a:t>
+            </a:r>
+            <a:endParaRPr lang="en-US" sz="1350" dirty="0"/>
+          </a:p>
+          <a:p>
+            <a:pPr marL="203200" indent="-203200">
+              <a:spcAft>
+                <a:spcPts val="1000"/>
+              </a:spcAft>
+              <a:buSzPct val="100000"/>
+              <a:buChar char="•"/>
+            </a:pPr>
+            <a:r>
+              <a:rPr lang="en-US" sz="1350" dirty="0">
+                <a:solidFill>
+                  <a:srgbClr val="172A38"/>
+                </a:solidFill>
+                <a:latin typeface="Calibri" pitchFamily="34" charset="0"/>
+                <a:ea typeface="Calibri" pitchFamily="34" charset="-122"/>
+                <a:cs typeface="Calibri" pitchFamily="34" charset="-120"/>
+              </a:rPr>
+              <a:t>Open question logged: SLA to rotate the shared support credential?</a:t>
+            </a:r>
+            <a:endParaRPr lang="en-US" sz="1350" dirty="0"/>
+          </a:p>
+          <a:p>
+            <a:pPr marL="203200" indent="-203200">
+              <a:spcAft>
+                <a:spcPts val="1000"/>
+              </a:spcAft>
+              <a:buSzPct val="100000"/>
+              <a:buChar char="•"/>
+            </a:pPr>
+            <a:r>
+              <a:rPr lang="en-US" sz="1350" dirty="0">
+                <a:solidFill>
+                  <a:srgbClr val="172A38"/>
+                </a:solidFill>
+                <a:latin typeface="Calibri" pitchFamily="34" charset="0"/>
+                <a:ea typeface="Calibri" pitchFamily="34" charset="-122"/>
+                <a:cs typeface="Calibri" pitchFamily="34" charset="-120"/>
+              </a:rPr>
+              <a:t>Model kept in version control so every change is diffable</a:t>
+            </a:r>
+            <a:endParaRPr lang="en-US" sz="1350" dirty="0"/>
+          </a:p>
+        </p:txBody>
+      </p:sp>
+      <p:sp>
+        <p:nvSpPr>
+          <p:cNvPr id="7" name="Shape 5"/>
+          <p:cNvSpPr/>
+          <p:nvPr/>
+        </p:nvSpPr>
+        <p:spPr>
+          <a:xfrm>
+            <a:off x="6355080" y="1536192"/>
+            <a:ext cx="5285232" cy="4709160"/>
+          </a:xfrm>
+          <a:prstGeom prst="roundRect">
+            <a:avLst>
+              <a:gd name="adj" fmla="val 1553"/>
+            </a:avLst>
+          </a:prstGeom>
+          <a:solidFill>
+            <a:srgbClr val="F0F5F9"/>
+          </a:solidFill>
+          <a:ln w="15875">
+            <a:solidFill>
+              <a:srgbClr val="065A82"/>
+            </a:solidFill>
+            <a:prstDash val="solid"/>
+          </a:ln>
+        </p:spPr>
+      </p:sp>
+      <p:sp>
+        <p:nvSpPr>
+          <p:cNvPr id="8" name="Shape 6"/>
+          <p:cNvSpPr/>
+          <p:nvPr/>
+        </p:nvSpPr>
+        <p:spPr>
+          <a:xfrm>
+            <a:off x="6629400" y="1783080"/>
+            <a:ext cx="384048" cy="384048"/>
+          </a:xfrm>
+          <a:prstGeom prst="ellipse">
+            <a:avLst/>
+          </a:prstGeom>
+          <a:solidFill>
+            <a:srgbClr val="065A82"/>
+          </a:solidFill>
+          <a:ln/>
+        </p:spPr>
+      </p:sp>
+      <p:sp>
+        <p:nvSpPr>
+          <p:cNvPr id="9" name="Text 7"/>
+          <p:cNvSpPr/>
+          <p:nvPr/>
+        </p:nvSpPr>
+        <p:spPr>
+          <a:xfrm>
+            <a:off x="7132320" y="1755648"/>
+            <a:ext cx="4279392" cy="411480"/>
+          </a:xfrm>
+          <a:prstGeom prst="rect">
+            <a:avLst/>
+          </a:prstGeom>
+          <a:noFill/>
+          <a:ln/>
+        </p:spPr>
+        <p:txBody>
+          <a:bodyPr wrap="square" lIns="0" tIns="0" rIns="0" bIns="0" rtlCol="0" anchor="ctr"/>
+          <a:lstStyle/>
+          <a:p>
+            <a:pPr indent="0" marL="0">
+              <a:buNone/>
+            </a:pPr>
+            <a:r>
+              <a:rPr lang="en-US" sz="1800" b="1" dirty="0">
+                <a:solidFill>
+                  <a:srgbClr val="065A82"/>
+                </a:solidFill>
+                <a:latin typeface="Cambria" pitchFamily="34" charset="0"/>
+                <a:ea typeface="Cambria" pitchFamily="34" charset="-122"/>
+                <a:cs typeface="Cambria" pitchFamily="34" charset="-120"/>
+              </a:rPr>
+              <a:t>What the FDA expects</a:t>
+            </a:r>
+            <a:endParaRPr lang="en-US" sz="1800" dirty="0"/>
+          </a:p>
+        </p:txBody>
+      </p:sp>
+      <p:sp>
+        <p:nvSpPr>
+          <p:cNvPr id="10" name="Text 8"/>
+          <p:cNvSpPr/>
+          <p:nvPr/>
+        </p:nvSpPr>
+        <p:spPr>
+          <a:xfrm>
+            <a:off x="6647688" y="2404872"/>
+            <a:ext cx="4700016" cy="3611880"/>
+          </a:xfrm>
+          <a:prstGeom prst="rect">
+            <a:avLst/>
+          </a:prstGeom>
+          <a:noFill/>
+          <a:ln/>
+        </p:spPr>
+        <p:txBody>
+          <a:bodyPr wrap="square" lIns="0" tIns="0" rIns="0" bIns="0" rtlCol="0" anchor="t"/>
+          <a:lstStyle/>
+          <a:p>
+            <a:pPr marL="203200" indent="-203200">
+              <a:spcAft>
+                <a:spcPts val="1100"/>
+              </a:spcAft>
+              <a:buSzPct val="100000"/>
+              <a:buChar char="•"/>
+            </a:pPr>
+            <a:r>
+              <a:rPr lang="en-US" sz="1350" dirty="0">
+                <a:solidFill>
+                  <a:srgbClr val="172A38"/>
+                </a:solidFill>
+                <a:latin typeface="Calibri" pitchFamily="34" charset="0"/>
+                <a:ea typeface="Calibri" pitchFamily="34" charset="-122"/>
+                <a:cs typeface="Calibri" pitchFamily="34" charset="-120"/>
+              </a:rPr>
+              <a:t>Maintain the model across the whole lifecycle — "maintain" is statutory (§524B(b)(2))</a:t>
+            </a:r>
+            <a:endParaRPr lang="en-US" sz="1350" dirty="0"/>
+          </a:p>
+          <a:p>
+            <a:pPr marL="203200" indent="-203200">
+              <a:spcAft>
+                <a:spcPts val="1100"/>
+              </a:spcAft>
+              <a:buSzPct val="100000"/>
+              <a:buChar char="•"/>
+            </a:pPr>
+            <a:r>
+              <a:rPr lang="en-US" sz="1350" dirty="0">
+                <a:solidFill>
+                  <a:srgbClr val="172A38"/>
+                </a:solidFill>
+                <a:latin typeface="Calibri" pitchFamily="34" charset="0"/>
+                <a:ea typeface="Calibri" pitchFamily="34" charset="-122"/>
+                <a:cs typeface="Calibri" pitchFamily="34" charset="-120"/>
+              </a:rPr>
+              <a:t>Re-trigger on: new feature, new interface, a disclosed vulnerability, an incident</a:t>
+            </a:r>
+            <a:endParaRPr lang="en-US" sz="1350" dirty="0"/>
+          </a:p>
+          <a:p>
+            <a:pPr marL="203200" indent="-203200">
+              <a:spcAft>
+                <a:spcPts val="1100"/>
+              </a:spcAft>
+              <a:buSzPct val="100000"/>
+              <a:buChar char="•"/>
+            </a:pPr>
+            <a:r>
+              <a:rPr lang="en-US" sz="1350" dirty="0">
+                <a:solidFill>
+                  <a:srgbClr val="172A38"/>
+                </a:solidFill>
+                <a:latin typeface="Calibri" pitchFamily="34" charset="0"/>
+                <a:ea typeface="Calibri" pitchFamily="34" charset="-122"/>
+                <a:cs typeface="Calibri" pitchFamily="34" charset="-120"/>
+              </a:rPr>
+              <a:t>Show end-to-end traceability: threat model ↔ risk assessment ↔ SBOM ↔ testing</a:t>
+            </a:r>
+            <a:endParaRPr lang="en-US" sz="1350" dirty="0"/>
+          </a:p>
+          <a:p>
+            <a:pPr marL="203200" indent="-203200">
+              <a:spcAft>
+                <a:spcPts val="1100"/>
+              </a:spcAft>
+              <a:buSzPct val="100000"/>
+              <a:buChar char="•"/>
+            </a:pPr>
+            <a:r>
+              <a:rPr lang="en-US" sz="1350" dirty="0">
+                <a:solidFill>
+                  <a:srgbClr val="172A38"/>
+                </a:solidFill>
+                <a:latin typeface="Calibri" pitchFamily="34" charset="0"/>
+                <a:ea typeface="Calibri" pitchFamily="34" charset="-122"/>
+                <a:cs typeface="Calibri" pitchFamily="34" charset="-120"/>
+              </a:rPr>
+              <a:t>Assess per fielded version; track patch % and time-to-patch metrics</a:t>
+            </a:r>
+            <a:endParaRPr lang="en-US" sz="1350" dirty="0"/>
+          </a:p>
+        </p:txBody>
+      </p:sp>
+    </p:spTree>
+  </p:cSld>
+  <p:clrMapOvr>
+    <a:masterClrMapping/>
+  </p:clrMapOvr>
+</p:sld>
+</file>
+
+<file path=ppt/slides/slide17.xml><?xml version="1.0" encoding="utf-8"?>
+<p:sld xmlns:a="http://schemas.openxmlformats.org/drawingml/2006/main" xmlns:r="http://schemas.openxmlformats.org/officeDocument/2006/relationships" xmlns:p="http://schemas.openxmlformats.org/presentationml/2006/main">
+  <p:cSld name="Slide 17">
+    <p:bg>
+      <p:bgPr>
+        <a:solidFill>
+          <a:srgbClr val="FFFFFF"/>
+        </a:solidFill>
+      </p:bgPr>
+    </p:bg>
+    <p:spTree>
+      <p:nvGrpSpPr>
+        <p:cNvPr id="1" name=""/>
+        <p:cNvGrpSpPr/>
+        <p:nvPr/>
+      </p:nvGrpSpPr>
+      <p:grpSpPr>
+        <a:xfrm>
+          <a:off x="0" y="0"/>
+          <a:ext cx="0" cy="0"/>
+          <a:chOff x="0" y="0"/>
+          <a:chExt cx="0" cy="0"/>
+        </a:xfrm>
+      </p:grpSpPr>
+      <p:sp>
+        <p:nvSpPr>
+          <p:cNvPr id="2" name="Text 0"/>
+          <p:cNvSpPr/>
+          <p:nvPr/>
+        </p:nvSpPr>
+        <p:spPr>
+          <a:xfrm>
+            <a:off x="566928" y="182880"/>
+            <a:ext cx="10972800" cy="274320"/>
+          </a:xfrm>
+          <a:prstGeom prst="rect">
+            <a:avLst/>
+          </a:prstGeom>
+          <a:noFill/>
+          <a:ln/>
+        </p:spPr>
+        <p:txBody>
+          <a:bodyPr wrap="square" lIns="0" tIns="0" rIns="0" bIns="0" rtlCol="0" anchor="ctr"/>
+          <a:lstStyle/>
+          <a:p>
+            <a:pPr algn="l" indent="0" marL="0">
+              <a:buNone/>
+            </a:pPr>
+            <a:r>
+              <a:rPr lang="en-US" sz="1300" b="1" spc="300" kern="0" dirty="0">
+                <a:solidFill>
+                  <a:srgbClr val="028090"/>
+                </a:solidFill>
+                <a:latin typeface="Calibri" pitchFamily="34" charset="0"/>
+                <a:ea typeface="Calibri" pitchFamily="34" charset="-122"/>
+                <a:cs typeface="Calibri" pitchFamily="34" charset="-120"/>
+              </a:rPr>
               <a:t>THE REGULATORY REALITY</a:t>
             </a:r>
             <a:endParaRPr lang="en-US" sz="1300" dirty="0"/>
@@ -4110,9 +6308,9 @@
 </p:sld>
 </file>
 
-<file path=ppt/slides/slide14.xml><?xml version="1.0" encoding="utf-8"?>
+<file path=ppt/slides/slide18.xml><?xml version="1.0" encoding="utf-8"?>
 <p:sld xmlns:a="http://schemas.openxmlformats.org/drawingml/2006/main" xmlns:r="http://schemas.openxmlformats.org/officeDocument/2006/relationships" xmlns:p="http://schemas.openxmlformats.org/presentationml/2006/main">
-  <p:cSld name="Slide 14">
+  <p:cSld name="Slide 18">
     <p:bg>
       <p:bgPr>
         <a:solidFill>
@@ -9007,7 +11205,7 @@
     <p:bg>
       <p:bgPr>
         <a:solidFill>
-          <a:srgbClr val="07253A"/>
+          <a:srgbClr val="FFFFFF"/>
         </a:solidFill>
       </p:bgPr>
     </p:bg>
@@ -9027,23 +11225,42 @@
       </p:grpSpPr>
       <p:sp>
         <p:nvSpPr>
-          <p:cNvPr id="2" name="Shape 0"/>
-          <p:cNvSpPr/>
-          <p:nvPr/>
-        </p:nvSpPr>
-        <p:spPr>
-          <a:xfrm>
-            <a:off x="640080" y="548640"/>
-            <a:ext cx="868680" cy="868680"/>
-          </a:xfrm>
-          <a:prstGeom prst="ellipse">
-            <a:avLst/>
-          </a:prstGeom>
-          <a:solidFill>
-            <a:srgbClr val="02C39A"/>
-          </a:solidFill>
-          <a:ln/>
-        </p:spPr>
+          <p:cNvPr id="2" name="Text 0"/>
+          <p:cNvSpPr/>
+          <p:nvPr/>
+        </p:nvSpPr>
+        <p:spPr>
+          <a:xfrm>
+            <a:off x="566928" y="182880"/>
+            <a:ext cx="10972800" cy="274320"/>
+          </a:xfrm>
+          <a:prstGeom prst="rect">
+            <a:avLst/>
+          </a:prstGeom>
+          <a:noFill/>
+          <a:ln/>
+        </p:spPr>
+        <p:txBody>
+          <a:bodyPr wrap="square" lIns="0" tIns="0" rIns="0" bIns="0" rtlCol="0" anchor="ctr"/>
+          <a:lstStyle/>
+          <a:p>
+            <a:pPr algn="l" indent="0" marL="0">
+              <a:buNone/>
+            </a:pPr>
+            <a:r>
+              <a:rPr lang="en-US" sz="1300" b="1" spc="300" kern="0" dirty="0">
+                <a:solidFill>
+                  <a:srgbClr val="028090"/>
+                </a:solidFill>
+                <a:latin typeface="Calibri" pitchFamily="34" charset="0"/>
+                <a:ea typeface="Calibri" pitchFamily="34" charset="-122"/>
+                <a:cs typeface="Calibri" pitchFamily="34" charset="-120"/>
+              </a:rPr>
+              <a:t>Q1 REFERENCE · LEAVE THIS UP WHILE YOU WORK</a:t>
+            </a:r>
+            <a:endParaRPr lang="en-US" sz="1300" dirty="0"/>
+          </a:p>
+        </p:txBody>
       </p:sp>
       <p:sp>
         <p:nvSpPr>
@@ -9053,47 +11270,69 @@
         </p:nvSpPr>
         <p:spPr>
           <a:xfrm>
-            <a:off x="640080" y="548640"/>
-            <a:ext cx="868680" cy="868680"/>
-          </a:xfrm>
-          <a:prstGeom prst="rect">
-            <a:avLst/>
-          </a:prstGeom>
-          <a:noFill/>
-          <a:ln/>
-        </p:spPr>
-        <p:txBody>
-          <a:bodyPr wrap="square" lIns="0" tIns="0" rIns="0" bIns="0" rtlCol="0" anchor="ctr"/>
-          <a:lstStyle/>
-          <a:p>
-            <a:pPr algn="ctr" indent="0" marL="0">
-              <a:buNone/>
-            </a:pPr>
-            <a:r>
-              <a:rPr lang="en-US" sz="2200" b="1" dirty="0">
-                <a:solidFill>
-                  <a:srgbClr val="07253A"/>
+            <a:off x="548640" y="411480"/>
+            <a:ext cx="11064240" cy="822960"/>
+          </a:xfrm>
+          <a:prstGeom prst="rect">
+            <a:avLst/>
+          </a:prstGeom>
+          <a:noFill/>
+          <a:ln/>
+        </p:spPr>
+        <p:txBody>
+          <a:bodyPr wrap="square" lIns="0" tIns="0" rIns="0" bIns="0" rtlCol="0" anchor="ctr"/>
+          <a:lstStyle/>
+          <a:p>
+            <a:pPr algn="l" indent="0" marL="0">
+              <a:buNone/>
+            </a:pPr>
+            <a:r>
+              <a:rPr lang="en-US" sz="3400" b="1" dirty="0">
+                <a:solidFill>
+                  <a:srgbClr val="065A82"/>
                 </a:solidFill>
                 <a:latin typeface="Cambria" pitchFamily="34" charset="0"/>
                 <a:ea typeface="Cambria" pitchFamily="34" charset="-122"/>
                 <a:cs typeface="Cambria" pitchFamily="34" charset="-120"/>
               </a:rPr>
-              <a:t>2</a:t>
-            </a:r>
-            <a:endParaRPr lang="en-US" sz="2200" dirty="0"/>
-          </a:p>
-        </p:txBody>
-      </p:sp>
-      <p:sp>
-        <p:nvSpPr>
-          <p:cNvPr id="4" name="Text 2"/>
-          <p:cNvSpPr/>
-          <p:nvPr/>
-        </p:nvSpPr>
-        <p:spPr>
-          <a:xfrm>
-            <a:off x="1737360" y="566928"/>
-            <a:ext cx="9875520" cy="868680"/>
+              <a:t>Q1 · Example &amp; what the FDA expects</a:t>
+            </a:r>
+            <a:endParaRPr lang="en-US" sz="3400" dirty="0"/>
+          </a:p>
+        </p:txBody>
+      </p:sp>
+      <p:sp>
+        <p:nvSpPr>
+          <p:cNvPr id="4" name="Shape 2"/>
+          <p:cNvSpPr/>
+          <p:nvPr/>
+        </p:nvSpPr>
+        <p:spPr>
+          <a:xfrm>
+            <a:off x="548640" y="1536192"/>
+            <a:ext cx="5486400" cy="4709160"/>
+          </a:xfrm>
+          <a:prstGeom prst="roundRect">
+            <a:avLst>
+              <a:gd name="adj" fmla="val 1553"/>
+            </a:avLst>
+          </a:prstGeom>
+          <a:solidFill>
+            <a:srgbClr val="EAF3F5"/>
+          </a:solidFill>
+          <a:ln/>
+        </p:spPr>
+      </p:sp>
+      <p:sp>
+        <p:nvSpPr>
+          <p:cNvPr id="5" name="Text 3"/>
+          <p:cNvSpPr/>
+          <p:nvPr/>
+        </p:nvSpPr>
+        <p:spPr>
+          <a:xfrm>
+            <a:off x="822960" y="1755648"/>
+            <a:ext cx="4937760" cy="457200"/>
           </a:xfrm>
           <a:prstGeom prst="rect">
             <a:avLst/>
@@ -9109,54 +11348,15 @@
               <a:buNone/>
             </a:pPr>
             <a:r>
-              <a:rPr lang="en-US" sz="3400" b="1" dirty="0">
-                <a:solidFill>
-                  <a:srgbClr val="FFFFFF"/>
+              <a:rPr lang="en-US" sz="1800" b="1" dirty="0">
+                <a:solidFill>
+                  <a:srgbClr val="028090"/>
                 </a:solidFill>
                 <a:latin typeface="Cambria" pitchFamily="34" charset="0"/>
                 <a:ea typeface="Cambria" pitchFamily="34" charset="-122"/>
                 <a:cs typeface="Cambria" pitchFamily="34" charset="-120"/>
               </a:rPr>
-              <a:t>What can go wrong?</a:t>
-            </a:r>
-            <a:endParaRPr lang="en-US" sz="3400" dirty="0"/>
-          </a:p>
-        </p:txBody>
-      </p:sp>
-      <p:sp>
-        <p:nvSpPr>
-          <p:cNvPr id="5" name="Text 3"/>
-          <p:cNvSpPr/>
-          <p:nvPr/>
-        </p:nvSpPr>
-        <p:spPr>
-          <a:xfrm>
-            <a:off x="658368" y="1645920"/>
-            <a:ext cx="10607040" cy="548640"/>
-          </a:xfrm>
-          <a:prstGeom prst="rect">
-            <a:avLst/>
-          </a:prstGeom>
-          <a:noFill/>
-          <a:ln/>
-        </p:spPr>
-        <p:txBody>
-          <a:bodyPr wrap="square" lIns="0" tIns="0" rIns="0" bIns="0" rtlCol="0" anchor="ctr"/>
-          <a:lstStyle/>
-          <a:p>
-            <a:pPr indent="0" marL="0">
-              <a:buNone/>
-            </a:pPr>
-            <a:r>
-              <a:rPr lang="en-US" sz="1800" i="1" dirty="0">
-                <a:solidFill>
-                  <a:srgbClr val="BFE0E8"/>
-                </a:solidFill>
-                <a:latin typeface="Calibri" pitchFamily="34" charset="0"/>
-                <a:ea typeface="Calibri" pitchFamily="34" charset="-122"/>
-                <a:cs typeface="Calibri" pitchFamily="34" charset="-120"/>
-              </a:rPr>
-              <a:t>Think like an attacker. Write ATTACKER STORIES.</a:t>
+              <a:t>Worked example — scope</a:t>
             </a:r>
             <a:endParaRPr lang="en-US" sz="1800" dirty="0"/>
           </a:p>
@@ -9164,26 +11364,132 @@
       </p:sp>
       <p:sp>
         <p:nvSpPr>
-          <p:cNvPr id="6" name="Shape 4"/>
-          <p:cNvSpPr/>
-          <p:nvPr/>
-        </p:nvSpPr>
-        <p:spPr>
-          <a:xfrm>
-            <a:off x="822960" y="2468880"/>
-            <a:ext cx="10515600" cy="1554480"/>
+          <p:cNvPr id="6" name="Text 4"/>
+          <p:cNvSpPr/>
+          <p:nvPr/>
+        </p:nvSpPr>
+        <p:spPr>
+          <a:xfrm>
+            <a:off x="841248" y="2359152"/>
+            <a:ext cx="4919472" cy="3657600"/>
+          </a:xfrm>
+          <a:prstGeom prst="rect">
+            <a:avLst/>
+          </a:prstGeom>
+          <a:noFill/>
+          <a:ln/>
+        </p:spPr>
+        <p:txBody>
+          <a:bodyPr wrap="square" lIns="0" tIns="0" rIns="0" bIns="0" rtlCol="0" anchor="t"/>
+          <a:lstStyle/>
+          <a:p>
+            <a:pPr marL="203200" indent="-203200">
+              <a:spcAft>
+                <a:spcPts val="1000"/>
+              </a:spcAft>
+              <a:buSzPct val="100000"/>
+              <a:buChar char="•"/>
+            </a:pPr>
+            <a:r>
+              <a:rPr lang="en-US" sz="1350" dirty="0">
+                <a:solidFill>
+                  <a:srgbClr val="172A38"/>
+                </a:solidFill>
+                <a:latin typeface="Calibri" pitchFamily="34" charset="0"/>
+                <a:ea typeface="Calibri" pitchFamily="34" charset="-122"/>
+                <a:cs typeface="Calibri" pitchFamily="34" charset="-120"/>
+              </a:rPr>
+              <a:t>In scope: imaging unit + firmware, acquisition workstation, local DICOM server, cloud AI service, update delivery</a:t>
+            </a:r>
+            <a:endParaRPr lang="en-US" sz="1350" dirty="0"/>
+          </a:p>
+          <a:p>
+            <a:pPr marL="203200" indent="-203200">
+              <a:spcAft>
+                <a:spcPts val="1000"/>
+              </a:spcAft>
+              <a:buSzPct val="100000"/>
+              <a:buChar char="•"/>
+            </a:pPr>
+            <a:r>
+              <a:rPr lang="en-US" sz="1350" dirty="0">
+                <a:solidFill>
+                  <a:srgbClr val="172A38"/>
+                </a:solidFill>
+                <a:latin typeface="Calibri" pitchFamily="34" charset="0"/>
+                <a:ea typeface="Calibri" pitchFamily="34" charset="-122"/>
+                <a:cs typeface="Calibri" pitchFamily="34" charset="-120"/>
+              </a:rPr>
+              <a:t>Out of scope: hospital EMR (partially trusted); hospital network (threat boundary)</a:t>
+            </a:r>
+            <a:endParaRPr lang="en-US" sz="1350" dirty="0"/>
+          </a:p>
+          <a:p>
+            <a:pPr marL="203200" indent="-203200">
+              <a:spcAft>
+                <a:spcPts val="1000"/>
+              </a:spcAft>
+              <a:buSzPct val="100000"/>
+              <a:buChar char="•"/>
+            </a:pPr>
+            <a:r>
+              <a:rPr lang="en-US" sz="1350" dirty="0">
+                <a:solidFill>
+                  <a:srgbClr val="172A38"/>
+                </a:solidFill>
+                <a:latin typeface="Calibri" pitchFamily="34" charset="0"/>
+                <a:ea typeface="Calibri" pitchFamily="34" charset="-122"/>
+                <a:cs typeface="Calibri" pitchFamily="34" charset="-120"/>
+              </a:rPr>
+              <a:t>Asset A-01: patient DICOM images (PHI) — Confidentiality + Integrity</a:t>
+            </a:r>
+            <a:endParaRPr lang="en-US" sz="1350" dirty="0"/>
+          </a:p>
+          <a:p>
+            <a:pPr marL="203200" indent="-203200">
+              <a:spcAft>
+                <a:spcPts val="1000"/>
+              </a:spcAft>
+              <a:buSzPct val="100000"/>
+              <a:buChar char="•"/>
+            </a:pPr>
+            <a:r>
+              <a:rPr lang="en-US" sz="1350" dirty="0">
+                <a:solidFill>
+                  <a:srgbClr val="172A38"/>
+                </a:solidFill>
+                <a:latin typeface="Calibri" pitchFamily="34" charset="0"/>
+                <a:ea typeface="Calibri" pitchFamily="34" charset="-122"/>
+                <a:cs typeface="Calibri" pitchFamily="34" charset="-120"/>
+              </a:rPr>
+              <a:t>Entry point: remote support (VPN + SSH, shared credential) — HIGH RISK</a:t>
+            </a:r>
+            <a:endParaRPr lang="en-US" sz="1350" dirty="0"/>
+          </a:p>
+        </p:txBody>
+      </p:sp>
+      <p:sp>
+        <p:nvSpPr>
+          <p:cNvPr id="7" name="Shape 5"/>
+          <p:cNvSpPr/>
+          <p:nvPr/>
+        </p:nvSpPr>
+        <p:spPr>
+          <a:xfrm>
+            <a:off x="6355080" y="1536192"/>
+            <a:ext cx="5285232" cy="4709160"/>
           </a:xfrm>
           <a:prstGeom prst="roundRect">
             <a:avLst>
-              <a:gd name="adj" fmla="val 7059"/>
+              <a:gd name="adj" fmla="val 1553"/>
             </a:avLst>
           </a:prstGeom>
           <a:solidFill>
-            <a:srgbClr val="0E3A55"/>
+            <a:srgbClr val="F0F5F9"/>
           </a:solidFill>
-          <a:ln w="19050">
+          <a:ln w="15875">
             <a:solidFill>
-              <a:srgbClr val="02C39A"/>
+              <a:srgbClr val="065A82"/>
             </a:solidFill>
             <a:prstDash val="solid"/>
           </a:ln>
@@ -9191,14 +11497,34 @@
       </p:sp>
       <p:sp>
         <p:nvSpPr>
-          <p:cNvPr id="7" name="Text 5"/>
-          <p:cNvSpPr/>
-          <p:nvPr/>
-        </p:nvSpPr>
-        <p:spPr>
-          <a:xfrm>
-            <a:off x="1097280" y="2468880"/>
-            <a:ext cx="9966960" cy="1554480"/>
+          <p:cNvPr id="8" name="Shape 6"/>
+          <p:cNvSpPr/>
+          <p:nvPr/>
+        </p:nvSpPr>
+        <p:spPr>
+          <a:xfrm>
+            <a:off x="6629400" y="1783080"/>
+            <a:ext cx="384048" cy="384048"/>
+          </a:xfrm>
+          <a:prstGeom prst="ellipse">
+            <a:avLst/>
+          </a:prstGeom>
+          <a:solidFill>
+            <a:srgbClr val="065A82"/>
+          </a:solidFill>
+          <a:ln/>
+        </p:spPr>
+      </p:sp>
+      <p:sp>
+        <p:nvSpPr>
+          <p:cNvPr id="9" name="Text 7"/>
+          <p:cNvSpPr/>
+          <p:nvPr/>
+        </p:nvSpPr>
+        <p:spPr>
+          <a:xfrm>
+            <a:off x="7132320" y="1755648"/>
+            <a:ext cx="4279392" cy="411480"/>
           </a:xfrm>
           <a:prstGeom prst="rect">
             <a:avLst/>
@@ -9211,220 +11537,126 @@
           <a:lstStyle/>
           <a:p>
             <a:pPr indent="0" marL="0">
-              <a:lnSpc>
-                <a:spcPct val="115000"/>
-              </a:lnSpc>
-              <a:buNone/>
-            </a:pPr>
-            <a:r>
-              <a:rPr lang="en-US" sz="2400" dirty="0">
-                <a:solidFill>
-                  <a:srgbClr val="BFE0E8"/>
+              <a:buNone/>
+            </a:pPr>
+            <a:r>
+              <a:rPr lang="en-US" sz="1800" b="1" dirty="0">
+                <a:solidFill>
+                  <a:srgbClr val="065A82"/>
                 </a:solidFill>
                 <a:latin typeface="Cambria" pitchFamily="34" charset="0"/>
                 <a:ea typeface="Cambria" pitchFamily="34" charset="-122"/>
                 <a:cs typeface="Cambria" pitchFamily="34" charset="-120"/>
               </a:rPr>
-              <a:t>As a </a:t>
-            </a:r>
-            <a:pPr indent="0" marL="0">
-              <a:lnSpc>
-                <a:spcPct val="115000"/>
-              </a:lnSpc>
-              <a:buNone/>
-            </a:pPr>
-            <a:r>
-              <a:rPr lang="en-US" sz="2400" b="1" dirty="0">
-                <a:solidFill>
-                  <a:srgbClr val="02C39A"/>
-                </a:solidFill>
-                <a:latin typeface="Cambria" pitchFamily="34" charset="0"/>
-                <a:ea typeface="Cambria" pitchFamily="34" charset="-122"/>
-                <a:cs typeface="Cambria" pitchFamily="34" charset="-120"/>
-              </a:rPr>
-              <a:t>[bad actor]</a:t>
-            </a:r>
-            <a:pPr indent="0" marL="0">
-              <a:lnSpc>
-                <a:spcPct val="115000"/>
-              </a:lnSpc>
-              <a:buNone/>
-            </a:pPr>
-            <a:r>
-              <a:rPr lang="en-US" sz="2400" dirty="0">
-                <a:solidFill>
-                  <a:srgbClr val="BFE0E8"/>
-                </a:solidFill>
-                <a:latin typeface="Cambria" pitchFamily="34" charset="0"/>
-                <a:ea typeface="Cambria" pitchFamily="34" charset="-122"/>
-                <a:cs typeface="Cambria" pitchFamily="34" charset="-120"/>
-              </a:rPr>
-              <a:t>, I want to </a:t>
-            </a:r>
-            <a:pPr indent="0" marL="0">
-              <a:lnSpc>
-                <a:spcPct val="115000"/>
-              </a:lnSpc>
-              <a:buNone/>
-            </a:pPr>
-            <a:r>
-              <a:rPr lang="en-US" sz="2400" b="1" dirty="0">
-                <a:solidFill>
-                  <a:srgbClr val="02C39A"/>
-                </a:solidFill>
-                <a:latin typeface="Cambria" pitchFamily="34" charset="0"/>
-                <a:ea typeface="Cambria" pitchFamily="34" charset="-122"/>
-                <a:cs typeface="Cambria" pitchFamily="34" charset="-120"/>
-              </a:rPr>
-              <a:t>[do something bad]</a:t>
-            </a:r>
-            <a:pPr indent="0" marL="0">
-              <a:lnSpc>
-                <a:spcPct val="115000"/>
-              </a:lnSpc>
-              <a:buNone/>
-            </a:pPr>
-            <a:r>
-              <a:rPr lang="en-US" sz="2400" dirty="0">
-                <a:solidFill>
-                  <a:srgbClr val="BFE0E8"/>
-                </a:solidFill>
-                <a:latin typeface="Cambria" pitchFamily="34" charset="0"/>
-                <a:ea typeface="Cambria" pitchFamily="34" charset="-122"/>
-                <a:cs typeface="Cambria" pitchFamily="34" charset="-120"/>
-              </a:rPr>
-              <a:t> via </a:t>
-            </a:r>
-            <a:pPr indent="0" marL="0">
-              <a:lnSpc>
-                <a:spcPct val="115000"/>
-              </a:lnSpc>
-              <a:buNone/>
-            </a:pPr>
-            <a:r>
-              <a:rPr lang="en-US" sz="2400" b="1" dirty="0">
-                <a:solidFill>
-                  <a:srgbClr val="02C39A"/>
-                </a:solidFill>
-                <a:latin typeface="Cambria" pitchFamily="34" charset="0"/>
-                <a:ea typeface="Cambria" pitchFamily="34" charset="-122"/>
-                <a:cs typeface="Cambria" pitchFamily="34" charset="-120"/>
-              </a:rPr>
-              <a:t>[method]</a:t>
-            </a:r>
-            <a:pPr indent="0" marL="0">
-              <a:lnSpc>
-                <a:spcPct val="115000"/>
-              </a:lnSpc>
-              <a:buNone/>
-            </a:pPr>
-            <a:r>
-              <a:rPr lang="en-US" sz="2400" dirty="0">
-                <a:solidFill>
-                  <a:srgbClr val="BFE0E8"/>
-                </a:solidFill>
-                <a:latin typeface="Cambria" pitchFamily="34" charset="0"/>
-                <a:ea typeface="Cambria" pitchFamily="34" charset="-122"/>
-                <a:cs typeface="Cambria" pitchFamily="34" charset="-120"/>
-              </a:rPr>
-              <a:t>, so that </a:t>
-            </a:r>
-            <a:pPr indent="0" marL="0">
-              <a:lnSpc>
-                <a:spcPct val="115000"/>
-              </a:lnSpc>
-              <a:buNone/>
-            </a:pPr>
-            <a:r>
-              <a:rPr lang="en-US" sz="2400" b="1" dirty="0">
-                <a:solidFill>
-                  <a:srgbClr val="02C39A"/>
-                </a:solidFill>
-                <a:latin typeface="Cambria" pitchFamily="34" charset="0"/>
-                <a:ea typeface="Cambria" pitchFamily="34" charset="-122"/>
-                <a:cs typeface="Cambria" pitchFamily="34" charset="-120"/>
-              </a:rPr>
-              <a:t>[goal].</a:t>
-            </a:r>
-            <a:endParaRPr lang="en-US" sz="2400" dirty="0"/>
-          </a:p>
-        </p:txBody>
-      </p:sp>
-      <p:sp>
-        <p:nvSpPr>
-          <p:cNvPr id="8" name="Text 6"/>
-          <p:cNvSpPr/>
-          <p:nvPr/>
-        </p:nvSpPr>
-        <p:spPr>
-          <a:xfrm>
-            <a:off x="822960" y="4251960"/>
-            <a:ext cx="10515600" cy="1005840"/>
-          </a:xfrm>
-          <a:prstGeom prst="rect">
-            <a:avLst/>
-          </a:prstGeom>
-          <a:noFill/>
-          <a:ln/>
-        </p:spPr>
-        <p:txBody>
-          <a:bodyPr wrap="square" lIns="0" tIns="0" rIns="0" bIns="0" rtlCol="0" anchor="ctr"/>
-          <a:lstStyle/>
-          <a:p>
-            <a:pPr indent="0" marL="0">
-              <a:buNone/>
-            </a:pPr>
-            <a:r>
-              <a:rPr lang="en-US" sz="1600" i="1" dirty="0">
-                <a:solidFill>
-                  <a:srgbClr val="CDE3EA"/>
-                </a:solidFill>
-                <a:latin typeface="Calibri" pitchFamily="34" charset="0"/>
-                <a:ea typeface="Calibri" pitchFamily="34" charset="-122"/>
-                <a:cs typeface="Calibri" pitchFamily="34" charset="-120"/>
-              </a:rPr>
-              <a:t>Example: As a rogue vendor technician, I want to change the AI model via the remote support channel, so that the system returns false negatives and patients are misdiagnosed.</a:t>
-            </a:r>
-            <a:endParaRPr lang="en-US" sz="1600" dirty="0"/>
-          </a:p>
-        </p:txBody>
-      </p:sp>
-      <p:sp>
-        <p:nvSpPr>
-          <p:cNvPr id="9" name="Text 7"/>
-          <p:cNvSpPr/>
-          <p:nvPr/>
-        </p:nvSpPr>
-        <p:spPr>
-          <a:xfrm>
-            <a:off x="822960" y="5440680"/>
-            <a:ext cx="10515600" cy="457200"/>
-          </a:xfrm>
-          <a:prstGeom prst="rect">
-            <a:avLst/>
-          </a:prstGeom>
-          <a:noFill/>
-          <a:ln/>
-        </p:spPr>
-        <p:txBody>
-          <a:bodyPr wrap="square" lIns="0" tIns="0" rIns="0" bIns="0" rtlCol="0" anchor="ctr"/>
-          <a:lstStyle/>
-          <a:p>
-            <a:pPr indent="0" marL="0">
-              <a:buNone/>
-            </a:pPr>
-            <a:r>
-              <a:rPr lang="en-US" sz="1600" b="1" dirty="0">
-                <a:solidFill>
-                  <a:srgbClr val="02C39A"/>
-                </a:solidFill>
-                <a:latin typeface="Calibri" pitchFamily="34" charset="0"/>
-                <a:ea typeface="Calibri" pitchFamily="34" charset="-122"/>
-                <a:cs typeface="Calibri" pitchFamily="34" charset="-120"/>
-              </a:rPr>
-              <a:t>Aim for at least 8 stories across different parts of the system.</a:t>
-            </a:r>
-            <a:endParaRPr lang="en-US" sz="1600" dirty="0"/>
+              <a:t>What the FDA expects</a:t>
+            </a:r>
+            <a:endParaRPr lang="en-US" sz="1800" dirty="0"/>
+          </a:p>
+        </p:txBody>
+      </p:sp>
+      <p:sp>
+        <p:nvSpPr>
+          <p:cNvPr id="10" name="Text 8"/>
+          <p:cNvSpPr/>
+          <p:nvPr/>
+        </p:nvSpPr>
+        <p:spPr>
+          <a:xfrm>
+            <a:off x="6647688" y="2404872"/>
+            <a:ext cx="4700016" cy="3611880"/>
+          </a:xfrm>
+          <a:prstGeom prst="rect">
+            <a:avLst/>
+          </a:prstGeom>
+          <a:noFill/>
+          <a:ln/>
+        </p:spPr>
+        <p:txBody>
+          <a:bodyPr wrap="square" lIns="0" tIns="0" rIns="0" bIns="0" rtlCol="0" anchor="t"/>
+          <a:lstStyle/>
+          <a:p>
+            <a:pPr marL="203200" indent="-203200">
+              <a:spcAft>
+                <a:spcPts val="1100"/>
+              </a:spcAft>
+              <a:buSzPct val="100000"/>
+              <a:buChar char="•"/>
+            </a:pPr>
+            <a:r>
+              <a:rPr lang="en-US" sz="1350" dirty="0">
+                <a:solidFill>
+                  <a:srgbClr val="172A38"/>
+                </a:solidFill>
+                <a:latin typeface="Calibri" pitchFamily="34" charset="0"/>
+                <a:ea typeface="Calibri" pitchFamily="34" charset="-122"/>
+                <a:cs typeface="Calibri" pitchFamily="34" charset="-120"/>
+              </a:rPr>
+              <a:t>Scope the whole medical device system — device + cloud + interoperable parts (§V.A.3)</a:t>
+            </a:r>
+            <a:endParaRPr lang="en-US" sz="1350" dirty="0"/>
+          </a:p>
+          <a:p>
+            <a:pPr marL="203200" indent="-203200">
+              <a:spcAft>
+                <a:spcPts val="1100"/>
+              </a:spcAft>
+              <a:buSzPct val="100000"/>
+              <a:buChar char="•"/>
+            </a:pPr>
+            <a:r>
+              <a:rPr lang="en-US" sz="1350" dirty="0">
+                <a:solidFill>
+                  <a:srgbClr val="172A38"/>
+                </a:solidFill>
+                <a:latin typeface="Calibri" pitchFamily="34" charset="0"/>
+                <a:ea typeface="Calibri" pitchFamily="34" charset="-122"/>
+                <a:cs typeface="Calibri" pitchFamily="34" charset="-120"/>
+              </a:rPr>
+              <a:t>Capture third-party / COTS components now — they become your SBOM (§524B(b)(3))</a:t>
+            </a:r>
+            <a:endParaRPr lang="en-US" sz="1350" dirty="0"/>
+          </a:p>
+          <a:p>
+            <a:pPr marL="203200" indent="-203200">
+              <a:spcAft>
+                <a:spcPts val="1100"/>
+              </a:spcAft>
+              <a:buSzPct val="100000"/>
+              <a:buChar char="•"/>
+            </a:pPr>
+            <a:r>
+              <a:rPr lang="en-US" sz="1350" dirty="0">
+                <a:solidFill>
+                  <a:srgbClr val="172A38"/>
+                </a:solidFill>
+                <a:latin typeface="Calibri" pitchFamily="34" charset="0"/>
+                <a:ea typeface="Calibri" pitchFamily="34" charset="-122"/>
+                <a:cs typeface="Calibri" pitchFamily="34" charset="-120"/>
+              </a:rPr>
+              <a:t>Give assets &amp; entry points stable IDs — the anchor for later traceability</a:t>
+            </a:r>
+            <a:endParaRPr lang="en-US" sz="1350" dirty="0"/>
+          </a:p>
+          <a:p>
+            <a:pPr marL="203200" indent="-203200">
+              <a:spcAft>
+                <a:spcPts val="1100"/>
+              </a:spcAft>
+              <a:buSzPct val="100000"/>
+              <a:buChar char="•"/>
+            </a:pPr>
+            <a:r>
+              <a:rPr lang="en-US" sz="1350" dirty="0">
+                <a:solidFill>
+                  <a:srgbClr val="172A38"/>
+                </a:solidFill>
+                <a:latin typeface="Calibri" pitchFamily="34" charset="0"/>
+                <a:ea typeface="Calibri" pitchFamily="34" charset="-122"/>
+                <a:cs typeface="Calibri" pitchFamily="34" charset="-120"/>
+              </a:rPr>
+              <a:t>Red flag: a boundary drawn around the device only, ignoring the cloud service</a:t>
+            </a:r>
+            <a:endParaRPr lang="en-US" sz="1350" dirty="0"/>
           </a:p>
         </p:txBody>
       </p:sp>

</xml_diff>

<commit_message>
Switch risk method to Exploitability x Severity (FDA-aligned) across template, docx, Q2, guide, prompts, slides
</commit_message>
<xml_diff>
--- a/slides/workshop-intro-slides.pptx
+++ b/slides/workshop-intro-slides.pptx
@@ -3138,11 +3138,11 @@
         <p:spPr>
           <a:xfrm>
             <a:off x="548640" y="1554480"/>
-            <a:ext cx="3566160" cy="2286000"/>
+            <a:ext cx="3566160" cy="2331720"/>
           </a:xfrm>
           <a:prstGeom prst="roundRect">
             <a:avLst>
-              <a:gd name="adj" fmla="val 3600"/>
+              <a:gd name="adj" fmla="val 3529"/>
             </a:avLst>
           </a:prstGeom>
           <a:solidFill>
@@ -3159,8 +3159,8 @@
         </p:nvSpPr>
         <p:spPr>
           <a:xfrm>
-            <a:off x="731520" y="1691640"/>
-            <a:ext cx="3200400" cy="457200"/>
+            <a:off x="731520" y="1664208"/>
+            <a:ext cx="3200400" cy="365760"/>
           </a:xfrm>
           <a:prstGeom prst="rect">
             <a:avLst/>
@@ -3176,7 +3176,7 @@
               <a:buNone/>
             </a:pPr>
             <a:r>
-              <a:rPr lang="en-US" sz="2000" b="1" dirty="0">
+              <a:rPr lang="en-US" sz="1900" b="1" dirty="0">
                 <a:solidFill>
                   <a:srgbClr val="028090"/>
                 </a:solidFill>
@@ -3184,9 +3184,9 @@
                 <a:ea typeface="Cambria" pitchFamily="34" charset="-122"/>
                 <a:cs typeface="Cambria" pitchFamily="34" charset="-120"/>
               </a:rPr>
-              <a:t>Likelihood</a:t>
-            </a:r>
-            <a:endParaRPr lang="en-US" sz="2000" dirty="0"/>
+              <a:t>Exploitability</a:t>
+            </a:r>
+            <a:endParaRPr lang="en-US" sz="1900" dirty="0"/>
           </a:p>
         </p:txBody>
       </p:sp>
@@ -3198,8 +3198,47 @@
         </p:nvSpPr>
         <p:spPr>
           <a:xfrm>
-            <a:off x="731520" y="2240280"/>
-            <a:ext cx="3200400" cy="1463040"/>
+            <a:off x="731520" y="2011680"/>
+            <a:ext cx="3200400" cy="274320"/>
+          </a:xfrm>
+          <a:prstGeom prst="rect">
+            <a:avLst/>
+          </a:prstGeom>
+          <a:noFill/>
+          <a:ln/>
+        </p:spPr>
+        <p:txBody>
+          <a:bodyPr wrap="square" lIns="0" tIns="0" rIns="0" bIns="0" rtlCol="0" anchor="ctr"/>
+          <a:lstStyle/>
+          <a:p>
+            <a:pPr indent="0" marL="0">
+              <a:buNone/>
+            </a:pPr>
+            <a:r>
+              <a:rPr lang="en-US" sz="1200" i="1" dirty="0">
+                <a:solidFill>
+                  <a:srgbClr val="5F7280"/>
+                </a:solidFill>
+                <a:latin typeface="Calibri" pitchFamily="34" charset="0"/>
+                <a:ea typeface="Calibri" pitchFamily="34" charset="-122"/>
+                <a:cs typeface="Calibri" pitchFamily="34" charset="-120"/>
+              </a:rPr>
+              <a:t>how feasible is the attack?</a:t>
+            </a:r>
+            <a:endParaRPr lang="en-US" sz="1200" dirty="0"/>
+          </a:p>
+        </p:txBody>
+      </p:sp>
+      <p:sp>
+        <p:nvSpPr>
+          <p:cNvPr id="7" name="Text 5"/>
+          <p:cNvSpPr/>
+          <p:nvPr/>
+        </p:nvSpPr>
+        <p:spPr>
+          <a:xfrm>
+            <a:off x="731520" y="2377440"/>
+            <a:ext cx="3246120" cy="1417320"/>
           </a:xfrm>
           <a:prstGeom prst="rect">
             <a:avLst/>
@@ -3213,12 +3252,12 @@
           <a:p>
             <a:pPr indent="0" marL="0">
               <a:spcAft>
-                <a:spcPts val="600"/>
+                <a:spcPts val="500"/>
               </a:spcAft>
               <a:buNone/>
             </a:pPr>
             <a:r>
-              <a:rPr lang="en-US" sz="1600" dirty="0">
+              <a:rPr lang="en-US" sz="1300" dirty="0">
                 <a:solidFill>
                   <a:srgbClr val="172A38"/>
                 </a:solidFill>
@@ -3226,19 +3265,19 @@
                 <a:ea typeface="Calibri" pitchFamily="34" charset="-122"/>
                 <a:cs typeface="Calibri" pitchFamily="34" charset="-120"/>
               </a:rPr>
-              <a:t>1  Hard</a:t>
-            </a:r>
-            <a:endParaRPr lang="en-US" sz="1600" dirty="0"/>
+              <a:t>1  Low — rare access / high skill</a:t>
+            </a:r>
+            <a:endParaRPr lang="en-US" sz="1300" dirty="0"/>
           </a:p>
           <a:p>
             <a:pPr indent="0" marL="0">
               <a:spcAft>
-                <a:spcPts val="600"/>
+                <a:spcPts val="500"/>
               </a:spcAft>
               <a:buNone/>
             </a:pPr>
             <a:r>
-              <a:rPr lang="en-US" sz="1600" dirty="0">
+              <a:rPr lang="en-US" sz="1300" dirty="0">
                 <a:solidFill>
                   <a:srgbClr val="172A38"/>
                 </a:solidFill>
@@ -3246,16 +3285,16 @@
                 <a:ea typeface="Calibri" pitchFamily="34" charset="-122"/>
                 <a:cs typeface="Calibri" pitchFamily="34" charset="-120"/>
               </a:rPr>
-              <a:t>2  Realistic</a:t>
-            </a:r>
-            <a:endParaRPr lang="en-US" sz="1600" dirty="0"/>
+              <a:t>2  Moderate — remote, known flaw</a:t>
+            </a:r>
+            <a:endParaRPr lang="en-US" sz="1300" dirty="0"/>
           </a:p>
           <a:p>
             <a:pPr indent="0" marL="0">
               <a:buNone/>
             </a:pPr>
             <a:r>
-              <a:rPr lang="en-US" sz="1600" dirty="0">
+              <a:rPr lang="en-US" sz="1300" dirty="0">
                 <a:solidFill>
                   <a:srgbClr val="172A38"/>
                 </a:solidFill>
@@ -3263,21 +3302,21 @@
                 <a:ea typeface="Calibri" pitchFamily="34" charset="-122"/>
                 <a:cs typeface="Calibri" pitchFamily="34" charset="-120"/>
               </a:rPr>
-              <a:t>3  Easy</a:t>
-            </a:r>
-            <a:endParaRPr lang="en-US" sz="1600" dirty="0"/>
-          </a:p>
-        </p:txBody>
-      </p:sp>
-      <p:sp>
-        <p:nvSpPr>
-          <p:cNvPr id="7" name="Text 5"/>
-          <p:cNvSpPr/>
-          <p:nvPr/>
-        </p:nvSpPr>
-        <p:spPr>
-          <a:xfrm>
-            <a:off x="4160520" y="2194560"/>
+              <a:t>3  High — trivial, public exploit</a:t>
+            </a:r>
+            <a:endParaRPr lang="en-US" sz="1300" dirty="0"/>
+          </a:p>
+        </p:txBody>
+      </p:sp>
+      <p:sp>
+        <p:nvSpPr>
+          <p:cNvPr id="8" name="Text 6"/>
+          <p:cNvSpPr/>
+          <p:nvPr/>
+        </p:nvSpPr>
+        <p:spPr>
+          <a:xfrm>
+            <a:off x="4160520" y="2240280"/>
             <a:ext cx="548640" cy="914400"/>
           </a:xfrm>
           <a:prstGeom prst="rect">
@@ -3310,18 +3349,18 @@
       </p:sp>
       <p:sp>
         <p:nvSpPr>
-          <p:cNvPr id="8" name="Shape 6"/>
+          <p:cNvPr id="9" name="Shape 7"/>
           <p:cNvSpPr/>
           <p:nvPr/>
         </p:nvSpPr>
         <p:spPr>
           <a:xfrm>
             <a:off x="4754880" y="1554480"/>
-            <a:ext cx="3566160" cy="2286000"/>
+            <a:ext cx="3566160" cy="2331720"/>
           </a:xfrm>
           <a:prstGeom prst="roundRect">
             <a:avLst>
-              <a:gd name="adj" fmla="val 3600"/>
+              <a:gd name="adj" fmla="val 3529"/>
             </a:avLst>
           </a:prstGeom>
           <a:solidFill>
@@ -3332,14 +3371,14 @@
       </p:sp>
       <p:sp>
         <p:nvSpPr>
-          <p:cNvPr id="9" name="Text 7"/>
-          <p:cNvSpPr/>
-          <p:nvPr/>
-        </p:nvSpPr>
-        <p:spPr>
-          <a:xfrm>
-            <a:off x="4937760" y="1691640"/>
-            <a:ext cx="3200400" cy="457200"/>
+          <p:cNvPr id="10" name="Text 8"/>
+          <p:cNvSpPr/>
+          <p:nvPr/>
+        </p:nvSpPr>
+        <p:spPr>
+          <a:xfrm>
+            <a:off x="4937760" y="1664208"/>
+            <a:ext cx="3200400" cy="365760"/>
           </a:xfrm>
           <a:prstGeom prst="rect">
             <a:avLst/>
@@ -3355,7 +3394,7 @@
               <a:buNone/>
             </a:pPr>
             <a:r>
-              <a:rPr lang="en-US" sz="2000" b="1" dirty="0">
+              <a:rPr lang="en-US" sz="1900" b="1" dirty="0">
                 <a:solidFill>
                   <a:srgbClr val="028090"/>
                 </a:solidFill>
@@ -3363,22 +3402,61 @@
                 <a:ea typeface="Cambria" pitchFamily="34" charset="-122"/>
                 <a:cs typeface="Cambria" pitchFamily="34" charset="-120"/>
               </a:rPr>
-              <a:t>Impact</a:t>
-            </a:r>
-            <a:endParaRPr lang="en-US" sz="2000" dirty="0"/>
-          </a:p>
-        </p:txBody>
-      </p:sp>
-      <p:sp>
-        <p:nvSpPr>
-          <p:cNvPr id="10" name="Text 8"/>
-          <p:cNvSpPr/>
-          <p:nvPr/>
-        </p:nvSpPr>
-        <p:spPr>
-          <a:xfrm>
-            <a:off x="4937760" y="2240280"/>
-            <a:ext cx="3200400" cy="1463040"/>
+              <a:t>Severity</a:t>
+            </a:r>
+            <a:endParaRPr lang="en-US" sz="1900" dirty="0"/>
+          </a:p>
+        </p:txBody>
+      </p:sp>
+      <p:sp>
+        <p:nvSpPr>
+          <p:cNvPr id="11" name="Text 9"/>
+          <p:cNvSpPr/>
+          <p:nvPr/>
+        </p:nvSpPr>
+        <p:spPr>
+          <a:xfrm>
+            <a:off x="4937760" y="2011680"/>
+            <a:ext cx="3200400" cy="274320"/>
+          </a:xfrm>
+          <a:prstGeom prst="rect">
+            <a:avLst/>
+          </a:prstGeom>
+          <a:noFill/>
+          <a:ln/>
+        </p:spPr>
+        <p:txBody>
+          <a:bodyPr wrap="square" lIns="0" tIns="0" rIns="0" bIns="0" rtlCol="0" anchor="ctr"/>
+          <a:lstStyle/>
+          <a:p>
+            <a:pPr indent="0" marL="0">
+              <a:buNone/>
+            </a:pPr>
+            <a:r>
+              <a:rPr lang="en-US" sz="1200" i="1" dirty="0">
+                <a:solidFill>
+                  <a:srgbClr val="5F7280"/>
+                </a:solidFill>
+                <a:latin typeface="Calibri" pitchFamily="34" charset="0"/>
+                <a:ea typeface="Calibri" pitchFamily="34" charset="-122"/>
+                <a:cs typeface="Calibri" pitchFamily="34" charset="-120"/>
+              </a:rPr>
+              <a:t>of patient harm</a:t>
+            </a:r>
+            <a:endParaRPr lang="en-US" sz="1200" dirty="0"/>
+          </a:p>
+        </p:txBody>
+      </p:sp>
+      <p:sp>
+        <p:nvSpPr>
+          <p:cNvPr id="12" name="Text 10"/>
+          <p:cNvSpPr/>
+          <p:nvPr/>
+        </p:nvSpPr>
+        <p:spPr>
+          <a:xfrm>
+            <a:off x="4937760" y="2377440"/>
+            <a:ext cx="3246120" cy="1417320"/>
           </a:xfrm>
           <a:prstGeom prst="rect">
             <a:avLst/>
@@ -3392,12 +3470,12 @@
           <a:p>
             <a:pPr indent="0" marL="0">
               <a:spcAft>
-                <a:spcPts val="600"/>
+                <a:spcPts val="500"/>
               </a:spcAft>
               <a:buNone/>
             </a:pPr>
             <a:r>
-              <a:rPr lang="en-US" sz="1600" dirty="0">
+              <a:rPr lang="en-US" sz="1300" dirty="0">
                 <a:solidFill>
                   <a:srgbClr val="172A38"/>
                 </a:solidFill>
@@ -3405,19 +3483,19 @@
                 <a:ea typeface="Calibri" pitchFamily="34" charset="-122"/>
                 <a:cs typeface="Calibri" pitchFamily="34" charset="-120"/>
               </a:rPr>
-              <a:t>1  Minor</a:t>
-            </a:r>
-            <a:endParaRPr lang="en-US" sz="1600" dirty="0"/>
+              <a:t>1  Minor — no patient harm</a:t>
+            </a:r>
+            <a:endParaRPr lang="en-US" sz="1300" dirty="0"/>
           </a:p>
           <a:p>
             <a:pPr indent="0" marL="0">
               <a:spcAft>
-                <a:spcPts val="600"/>
+                <a:spcPts val="500"/>
               </a:spcAft>
               <a:buNone/>
             </a:pPr>
             <a:r>
-              <a:rPr lang="en-US" sz="1600" dirty="0">
+              <a:rPr lang="en-US" sz="1300" dirty="0">
                 <a:solidFill>
                   <a:srgbClr val="172A38"/>
                 </a:solidFill>
@@ -3425,16 +3503,16 @@
                 <a:ea typeface="Calibri" pitchFamily="34" charset="-122"/>
                 <a:cs typeface="Calibri" pitchFamily="34" charset="-120"/>
               </a:rPr>
-              <a:t>2  Significant</a:t>
-            </a:r>
-            <a:endParaRPr lang="en-US" sz="1600" dirty="0"/>
+              <a:t>2  Significant — care delayed / breach</a:t>
+            </a:r>
+            <a:endParaRPr lang="en-US" sz="1300" dirty="0"/>
           </a:p>
           <a:p>
             <a:pPr indent="0" marL="0">
               <a:buNone/>
             </a:pPr>
             <a:r>
-              <a:rPr lang="en-US" sz="1600" dirty="0">
+              <a:rPr lang="en-US" sz="1300" dirty="0">
                 <a:solidFill>
                   <a:srgbClr val="172A38"/>
                 </a:solidFill>
@@ -3442,26 +3520,26 @@
                 <a:ea typeface="Calibri" pitchFamily="34" charset="-122"/>
                 <a:cs typeface="Calibri" pitchFamily="34" charset="-120"/>
               </a:rPr>
-              <a:t>3  Serious</a:t>
-            </a:r>
-            <a:endParaRPr lang="en-US" sz="1600" dirty="0"/>
-          </a:p>
-        </p:txBody>
-      </p:sp>
-      <p:sp>
-        <p:nvSpPr>
-          <p:cNvPr id="11" name="Shape 9"/>
+              <a:t>3  Serious — direct patient harm</a:t>
+            </a:r>
+            <a:endParaRPr lang="en-US" sz="1300" dirty="0"/>
+          </a:p>
+        </p:txBody>
+      </p:sp>
+      <p:sp>
+        <p:nvSpPr>
+          <p:cNvPr id="13" name="Shape 11"/>
           <p:cNvSpPr/>
           <p:nvPr/>
         </p:nvSpPr>
         <p:spPr>
           <a:xfrm>
             <a:off x="8686800" y="1554480"/>
-            <a:ext cx="2926080" cy="2286000"/>
+            <a:ext cx="2926080" cy="2331720"/>
           </a:xfrm>
           <a:prstGeom prst="roundRect">
             <a:avLst>
-              <a:gd name="adj" fmla="val 3600"/>
+              <a:gd name="adj" fmla="val 3529"/>
             </a:avLst>
           </a:prstGeom>
           <a:solidFill>
@@ -3472,14 +3550,14 @@
       </p:sp>
       <p:sp>
         <p:nvSpPr>
-          <p:cNvPr id="12" name="Text 10"/>
-          <p:cNvSpPr/>
-          <p:nvPr/>
-        </p:nvSpPr>
-        <p:spPr>
-          <a:xfrm>
-            <a:off x="8869680" y="1691640"/>
-            <a:ext cx="2560320" cy="457200"/>
+          <p:cNvPr id="14" name="Text 12"/>
+          <p:cNvSpPr/>
+          <p:nvPr/>
+        </p:nvSpPr>
+        <p:spPr>
+          <a:xfrm>
+            <a:off x="8869680" y="1664208"/>
+            <a:ext cx="2560320" cy="365760"/>
           </a:xfrm>
           <a:prstGeom prst="rect">
             <a:avLst/>
@@ -3495,7 +3573,7 @@
               <a:buNone/>
             </a:pPr>
             <a:r>
-              <a:rPr lang="en-US" sz="2000" b="1" dirty="0">
+              <a:rPr lang="en-US" sz="1900" b="1" dirty="0">
                 <a:solidFill>
                   <a:srgbClr val="02C39A"/>
                 </a:solidFill>
@@ -3505,20 +3583,59 @@
               </a:rPr>
               <a:t>Risk</a:t>
             </a:r>
-            <a:endParaRPr lang="en-US" sz="2000" dirty="0"/>
-          </a:p>
-        </p:txBody>
-      </p:sp>
-      <p:sp>
-        <p:nvSpPr>
-          <p:cNvPr id="13" name="Text 11"/>
-          <p:cNvSpPr/>
-          <p:nvPr/>
-        </p:nvSpPr>
-        <p:spPr>
-          <a:xfrm>
-            <a:off x="8869680" y="2240280"/>
-            <a:ext cx="2560320" cy="1463040"/>
+            <a:endParaRPr lang="en-US" sz="1900" dirty="0"/>
+          </a:p>
+        </p:txBody>
+      </p:sp>
+      <p:sp>
+        <p:nvSpPr>
+          <p:cNvPr id="15" name="Text 13"/>
+          <p:cNvSpPr/>
+          <p:nvPr/>
+        </p:nvSpPr>
+        <p:spPr>
+          <a:xfrm>
+            <a:off x="8869680" y="2011680"/>
+            <a:ext cx="2560320" cy="274320"/>
+          </a:xfrm>
+          <a:prstGeom prst="rect">
+            <a:avLst/>
+          </a:prstGeom>
+          <a:noFill/>
+          <a:ln/>
+        </p:spPr>
+        <p:txBody>
+          <a:bodyPr wrap="square" lIns="0" tIns="0" rIns="0" bIns="0" rtlCol="0" anchor="ctr"/>
+          <a:lstStyle/>
+          <a:p>
+            <a:pPr indent="0" marL="0">
+              <a:buNone/>
+            </a:pPr>
+            <a:r>
+              <a:rPr lang="en-US" sz="1200" i="1" dirty="0">
+                <a:solidFill>
+                  <a:srgbClr val="9DC6D2"/>
+                </a:solidFill>
+                <a:latin typeface="Calibri" pitchFamily="34" charset="0"/>
+                <a:ea typeface="Calibri" pitchFamily="34" charset="-122"/>
+                <a:cs typeface="Calibri" pitchFamily="34" charset="-120"/>
+              </a:rPr>
+              <a:t>exploitability × severity</a:t>
+            </a:r>
+            <a:endParaRPr lang="en-US" sz="1200" dirty="0"/>
+          </a:p>
+        </p:txBody>
+      </p:sp>
+      <p:sp>
+        <p:nvSpPr>
+          <p:cNvPr id="16" name="Text 14"/>
+          <p:cNvSpPr/>
+          <p:nvPr/>
+        </p:nvSpPr>
+        <p:spPr>
+          <a:xfrm>
+            <a:off x="8869680" y="2377440"/>
+            <a:ext cx="2560320" cy="1417320"/>
           </a:xfrm>
           <a:prstGeom prst="rect">
             <a:avLst/>
@@ -3532,12 +3649,12 @@
           <a:p>
             <a:pPr indent="0" marL="0">
               <a:spcAft>
-                <a:spcPts val="600"/>
+                <a:spcPts val="500"/>
               </a:spcAft>
               <a:buNone/>
             </a:pPr>
             <a:r>
-              <a:rPr lang="en-US" sz="1600" dirty="0">
+              <a:rPr lang="en-US" sz="1400" dirty="0">
                 <a:solidFill>
                   <a:srgbClr val="FFFFFF"/>
                 </a:solidFill>
@@ -3547,17 +3664,17 @@
               </a:rPr>
               <a:t>1–2  Low</a:t>
             </a:r>
-            <a:endParaRPr lang="en-US" sz="1600" dirty="0"/>
+            <a:endParaRPr lang="en-US" sz="1400" dirty="0"/>
           </a:p>
           <a:p>
             <a:pPr indent="0" marL="0">
               <a:spcAft>
-                <a:spcPts val="600"/>
+                <a:spcPts val="500"/>
               </a:spcAft>
               <a:buNone/>
             </a:pPr>
             <a:r>
-              <a:rPr lang="en-US" sz="1600" dirty="0">
+              <a:rPr lang="en-US" sz="1400" dirty="0">
                 <a:solidFill>
                   <a:srgbClr val="FFFFFF"/>
                 </a:solidFill>
@@ -3567,14 +3684,14 @@
               </a:rPr>
               <a:t>3–4  Medium</a:t>
             </a:r>
-            <a:endParaRPr lang="en-US" sz="1600" dirty="0"/>
+            <a:endParaRPr lang="en-US" sz="1400" dirty="0"/>
           </a:p>
           <a:p>
             <a:pPr indent="0" marL="0">
               <a:buNone/>
             </a:pPr>
             <a:r>
-              <a:rPr lang="en-US" sz="1600" dirty="0">
+              <a:rPr lang="en-US" sz="1400" dirty="0">
                 <a:solidFill>
                   <a:srgbClr val="FFFFFF"/>
                 </a:solidFill>
@@ -3584,13 +3701,13 @@
               </a:rPr>
               <a:t>6–9  High</a:t>
             </a:r>
-            <a:endParaRPr lang="en-US" sz="1600" dirty="0"/>
-          </a:p>
-        </p:txBody>
-      </p:sp>
-      <p:sp>
-        <p:nvSpPr>
-          <p:cNvPr id="14" name="Shape 12"/>
+            <a:endParaRPr lang="en-US" sz="1400" dirty="0"/>
+          </a:p>
+        </p:txBody>
+      </p:sp>
+      <p:sp>
+        <p:nvSpPr>
+          <p:cNvPr id="17" name="Shape 15"/>
           <p:cNvSpPr/>
           <p:nvPr/>
         </p:nvSpPr>
@@ -3617,7 +3734,7 @@
       </p:sp>
       <p:sp>
         <p:nvSpPr>
-          <p:cNvPr id="15" name="Text 13"/>
+          <p:cNvPr id="18" name="Text 16"/>
           <p:cNvSpPr/>
           <p:nvPr/>
         </p:nvSpPr>
@@ -3656,7 +3773,7 @@
       </p:sp>
       <p:sp>
         <p:nvSpPr>
-          <p:cNvPr id="16" name="Text 14"/>
+          <p:cNvPr id="19" name="Text 17"/>
           <p:cNvSpPr/>
           <p:nvPr/>
         </p:nvSpPr>
@@ -3922,7 +4039,7 @@
                 <a:ea typeface="Calibri" pitchFamily="34" charset="-122"/>
                 <a:cs typeface="Calibri" pitchFamily="34" charset="-120"/>
               </a:rPr>
-              <a:t>Likelihood 3 (no MFA, no rate-limit) × Impact 3 (full compromise) = 9</a:t>
+              <a:t>Exploitability 3 (no MFA, no rate-limit) × Severity 3 (full compromise) = 9</a:t>
             </a:r>
             <a:endParaRPr lang="en-US" sz="1350" dirty="0"/>
           </a:p>

</xml_diff>

<commit_message>
Broaden severity to cover privacy/availability harm; add S/P/A impact-type tag and STRIDE/CVSS real-engagement notes across template, docx, Q2, guide, prompt, slides
</commit_message>
<xml_diff>
--- a/slides/workshop-intro-slides.pptx
+++ b/slides/workshop-intro-slides.pptx
@@ -2988,8 +2988,8 @@
         </p:nvSpPr>
         <p:spPr>
           <a:xfrm>
-            <a:off x="822960" y="5440680"/>
-            <a:ext cx="10515600" cy="457200"/>
+            <a:off x="822960" y="5394960"/>
+            <a:ext cx="10515600" cy="365760"/>
           </a:xfrm>
           <a:prstGeom prst="rect">
             <a:avLst/>
@@ -3016,6 +3016,45 @@
               <a:t>Aim for at least 8 stories across different parts of the system.</a:t>
             </a:r>
             <a:endParaRPr lang="en-US" sz="1600" dirty="0"/>
+          </a:p>
+        </p:txBody>
+      </p:sp>
+      <p:sp>
+        <p:nvSpPr>
+          <p:cNvPr id="10" name="Text 8"/>
+          <p:cNvSpPr/>
+          <p:nvPr/>
+        </p:nvSpPr>
+        <p:spPr>
+          <a:xfrm>
+            <a:off x="822960" y="5806440"/>
+            <a:ext cx="10515600" cy="365760"/>
+          </a:xfrm>
+          <a:prstGeom prst="rect">
+            <a:avLst/>
+          </a:prstGeom>
+          <a:noFill/>
+          <a:ln/>
+        </p:spPr>
+        <p:txBody>
+          <a:bodyPr wrap="square" lIns="0" tIns="0" rIns="0" bIns="0" rtlCol="0" anchor="ctr"/>
+          <a:lstStyle/>
+          <a:p>
+            <a:pPr indent="0" marL="0">
+              <a:buNone/>
+            </a:pPr>
+            <a:r>
+              <a:rPr lang="en-US" sz="1400" i="1" dirty="0">
+                <a:solidFill>
+                  <a:srgbClr val="9FC3D0"/>
+                </a:solidFill>
+                <a:latin typeface="Calibri" pitchFamily="34" charset="0"/>
+                <a:ea typeface="Calibri" pitchFamily="34" charset="-122"/>
+                <a:cs typeface="Calibri" pitchFamily="34" charset="-120"/>
+              </a:rPr>
+              <a:t>Tag each story's impact type — S = patient safety · P = privacy/PHI · A = availability.</a:t>
+            </a:r>
+            <a:endParaRPr lang="en-US" sz="1400" dirty="0"/>
           </a:p>
         </p:txBody>
       </p:sp>
@@ -3402,7 +3441,7 @@
                 <a:ea typeface="Cambria" pitchFamily="34" charset="-122"/>
                 <a:cs typeface="Cambria" pitchFamily="34" charset="-120"/>
               </a:rPr>
-              <a:t>Severity</a:t>
+              <a:t>Severity of harm</a:t>
             </a:r>
             <a:endParaRPr lang="en-US" sz="1900" dirty="0"/>
           </a:p>
@@ -3441,7 +3480,7 @@
                 <a:ea typeface="Calibri" pitchFamily="34" charset="-122"/>
                 <a:cs typeface="Calibri" pitchFamily="34" charset="-120"/>
               </a:rPr>
-              <a:t>of patient harm</a:t>
+              <a:t>safety · privacy · availability</a:t>
             </a:r>
             <a:endParaRPr lang="en-US" sz="1200" dirty="0"/>
           </a:p>
@@ -3483,7 +3522,7 @@
                 <a:ea typeface="Calibri" pitchFamily="34" charset="-122"/>
                 <a:cs typeface="Calibri" pitchFamily="34" charset="-120"/>
               </a:rPr>
-              <a:t>1  Minor — no patient harm</a:t>
+              <a:t>1  Minor — no real harm</a:t>
             </a:r>
             <a:endParaRPr lang="en-US" sz="1300" dirty="0"/>
           </a:p>
@@ -3503,7 +3542,7 @@
                 <a:ea typeface="Calibri" pitchFamily="34" charset="-122"/>
                 <a:cs typeface="Calibri" pitchFamily="34" charset="-120"/>
               </a:rPr>
-              <a:t>2  Significant — care delayed / breach</a:t>
+              <a:t>2  Significant — delay, breach, downtime</a:t>
             </a:r>
             <a:endParaRPr lang="en-US" sz="1300" dirty="0"/>
           </a:p>
@@ -3520,7 +3559,7 @@
                 <a:ea typeface="Calibri" pitchFamily="34" charset="-122"/>
                 <a:cs typeface="Calibri" pitchFamily="34" charset="-120"/>
               </a:rPr>
-              <a:t>3  Serious — direct patient harm</a:t>
+              <a:t>3  Serious — patient harm or major breach</a:t>
             </a:r>
             <a:endParaRPr lang="en-US" sz="1300" dirty="0"/>
           </a:p>
@@ -3807,6 +3846,45 @@
               <a:t>If a story could directly harm a patient — wrong diagnosis acted on, device down in an emergency — mark it HIGH regardless of the score, and note why.</a:t>
             </a:r>
             <a:endParaRPr lang="en-US" sz="1550" dirty="0"/>
+          </a:p>
+        </p:txBody>
+      </p:sp>
+      <p:sp>
+        <p:nvSpPr>
+          <p:cNvPr id="20" name="Text 18"/>
+          <p:cNvSpPr/>
+          <p:nvPr/>
+        </p:nvSpPr>
+        <p:spPr>
+          <a:xfrm>
+            <a:off x="548640" y="5806440"/>
+            <a:ext cx="11064240" cy="548640"/>
+          </a:xfrm>
+          <a:prstGeom prst="rect">
+            <a:avLst/>
+          </a:prstGeom>
+          <a:noFill/>
+          <a:ln/>
+        </p:spPr>
+        <p:txBody>
+          <a:bodyPr wrap="square" lIns="0" tIns="0" rIns="0" bIns="0" rtlCol="0" anchor="ctr"/>
+          <a:lstStyle/>
+          <a:p>
+            <a:pPr indent="0" marL="0">
+              <a:buNone/>
+            </a:pPr>
+            <a:r>
+              <a:rPr lang="en-US" sz="1300" i="1" dirty="0">
+                <a:solidFill>
+                  <a:srgbClr val="5F7280"/>
+                </a:solidFill>
+                <a:latin typeface="Calibri" pitchFamily="34" charset="0"/>
+                <a:ea typeface="Calibri" pitchFamily="34" charset="-122"/>
+                <a:cs typeface="Calibri" pitchFamily="34" charset="-120"/>
+              </a:rPr>
+              <a:t>In a real engagement, teams layer STRIDE (systematic threat enumeration) and CVSS (standardized scoring, adapted for patient-safety severity) on top of this teaching scale.</a:t>
+            </a:r>
+            <a:endParaRPr lang="en-US" sz="1300" dirty="0"/>
           </a:p>
         </p:txBody>
       </p:sp>

</xml_diff>